<commit_message>
Add 1/2/3-day badging tiers to simulation, summary, and slides
Co-authored-by: et844p <et844p@users.noreply.github.com>
</commit_message>
<xml_diff>
--- a/output/safavieh/Safavieh_CEO_June_MSBD.pptx
+++ b/output/safavieh/Safavieh_CEO_June_MSBD.pptx
@@ -3366,7 +3366,7 @@
               </a:defRPr>
             </a:pPr>
             <a:r>
-              <a:t>• 84.7% fast-badge coverage (stated order-to-delivery ≤ 5 days)</a:t>
+              <a:t>• Badging today: 0.5% 1-day · 9.5% 2-day · 42.5% 3-day · 84.7% fast</a:t>
             </a:r>
           </a:p>
         </p:txBody>
@@ -3401,7 +3401,7 @@
               </a:defRPr>
             </a:pPr>
             <a:r>
-              <a:t>• 68.3% same-day induction for orders placed before 2pm — network gap</a:t>
+              <a:t>• Full policy sim: 6.3% 1-day · 26.4% 2-day · 59.5% 3-day · 86.9% fast</a:t>
             </a:r>
           </a:p>
         </p:txBody>
@@ -3436,7 +3436,7 @@
               </a:defRPr>
             </a:pPr>
             <a:r>
-              <a:t>• Policy stack (2pm + no cushion + weekend) → 86.9% fast badge (+2.2 pp)</a:t>
+              <a:t>• +17 pp uplift at 2- and 3-day tiers — bigger than fast badge (+2 pp)</a:t>
             </a:r>
           </a:p>
         </p:txBody>
@@ -3471,7 +3471,7 @@
               </a:defRPr>
             </a:pPr>
             <a:r>
-              <a:t>• Framing: policy unlocks badge; same-day induction is what customers experience</a:t>
+              <a:t>• 68.3% same-day induction before 2pm — operational proof point</a:t>
             </a:r>
           </a:p>
         </p:txBody>
@@ -5150,8 +5150,8 @@
         </p:nvSpPr>
         <p:spPr>
           <a:xfrm>
-            <a:off x="548640" y="365760"/>
-            <a:ext cx="10972800" cy="731520"/>
+            <a:off x="365760" y="228600"/>
+            <a:ext cx="10972800" cy="548640"/>
           </a:xfrm>
           <a:prstGeom prst="rect">
             <a:avLst/>
@@ -5165,14 +5165,14 @@
           <a:lstStyle/>
           <a:p>
             <a:pPr algn="l">
-              <a:defRPr sz="2800" b="1">
+              <a:defRPr sz="2400" b="1">
                 <a:solidFill>
                   <a:srgbClr val="1A365D"/>
                 </a:solidFill>
               </a:defRPr>
             </a:pPr>
             <a:r>
-              <a:t>Fast-badge simulation (June MSBD)</a:t>
+              <a:t>Badging simulation — all speed tiers (June MSBD)</a:t>
             </a:r>
           </a:p>
         </p:txBody>
@@ -5186,8 +5186,8 @@
           <p:nvPr/>
         </p:nvGraphicFramePr>
         <p:xfrm>
-          <a:off x="914400" y="1463040"/>
-          <a:ext cx="9601200" cy="1828800"/>
+          <a:off x="457200" y="914400"/>
+          <a:ext cx="11247120" cy="1737360"/>
         </p:xfrm>
         <a:graphic>
           <a:graphicData uri="http://schemas.openxmlformats.org/drawingml/2006/table">
@@ -5196,19 +5196,20 @@
                 <a:tableStyleId>{5C22544A-7EE6-4342-B048-85BDC9FD1C3A}</a:tableStyleId>
               </a:tblPr>
               <a:tblGrid>
-                <a:gridCol w="2400300"/>
-                <a:gridCol w="2400300"/>
-                <a:gridCol w="2400300"/>
-                <a:gridCol w="2400300"/>
+                <a:gridCol w="2249424"/>
+                <a:gridCol w="2249424"/>
+                <a:gridCol w="2249424"/>
+                <a:gridCol w="2249424"/>
+                <a:gridCol w="2249424"/>
               </a:tblGrid>
-              <a:tr h="457200">
-                <a:tc>
-                  <a:txBody>
-                    <a:bodyPr/>
-                    <a:lstStyle/>
-                    <a:p>
-                      <a:pPr>
-                        <a:defRPr b="1" sz="1400">
+              <a:tr h="347472">
+                <a:tc>
+                  <a:txBody>
+                    <a:bodyPr/>
+                    <a:lstStyle/>
+                    <a:p>
+                      <a:pPr>
+                        <a:defRPr b="1" sz="1200">
                           <a:solidFill>
                             <a:srgbClr val="FFFFFF"/>
                           </a:solidFill>
@@ -5231,14 +5232,14 @@
                     <a:lstStyle/>
                     <a:p>
                       <a:pPr>
-                        <a:defRPr b="1" sz="1400">
+                        <a:defRPr b="1" sz="1200">
                           <a:solidFill>
                             <a:srgbClr val="FFFFFF"/>
                           </a:solidFill>
                         </a:defRPr>
                       </a:pPr>
                       <a:r>
-                        <a:t>Fast-badge %</a:t>
+                        <a:t>1-day</a:t>
                       </a:r>
                     </a:p>
                   </a:txBody>
@@ -5254,14 +5255,14 @@
                     <a:lstStyle/>
                     <a:p>
                       <a:pPr>
-                        <a:defRPr b="1" sz="1400">
+                        <a:defRPr b="1" sz="1200">
                           <a:solidFill>
                             <a:srgbClr val="FFFFFF"/>
                           </a:solidFill>
                         </a:defRPr>
                       </a:pPr>
                       <a:r>
-                        <a:t>Uplift</a:t>
+                        <a:t>2-day</a:t>
                       </a:r>
                     </a:p>
                   </a:txBody>
@@ -5277,14 +5278,14 @@
                     <a:lstStyle/>
                     <a:p>
                       <a:pPr>
-                        <a:defRPr b="1" sz="1400">
+                        <a:defRPr b="1" sz="1200">
                           <a:solidFill>
                             <a:srgbClr val="FFFFFF"/>
                           </a:solidFill>
                         </a:defRPr>
                       </a:pPr>
                       <a:r>
-                        <a:t>Newly fast</a:t>
+                        <a:t>3-day</a:t>
                       </a:r>
                     </a:p>
                   </a:txBody>
@@ -5294,15 +5295,38 @@
                     </a:solidFill>
                   </a:tcPr>
                 </a:tc>
+                <a:tc>
+                  <a:txBody>
+                    <a:bodyPr/>
+                    <a:lstStyle/>
+                    <a:p>
+                      <a:pPr>
+                        <a:defRPr b="1" sz="1200">
+                          <a:solidFill>
+                            <a:srgbClr val="FFFFFF"/>
+                          </a:solidFill>
+                        </a:defRPr>
+                      </a:pPr>
+                      <a:r>
+                        <a:t>Fast ≤5d</a:t>
+                      </a:r>
+                    </a:p>
+                  </a:txBody>
+                  <a:tcPr>
+                    <a:solidFill>
+                      <a:srgbClr val="1A365D"/>
+                    </a:solidFill>
+                  </a:tcPr>
+                </a:tc>
               </a:tr>
-              <a:tr h="457200">
-                <a:tc>
-                  <a:txBody>
-                    <a:bodyPr/>
-                    <a:lstStyle/>
-                    <a:p>
-                      <a:pPr>
-                        <a:defRPr sz="1400"/>
+              <a:tr h="347472">
+                <a:tc>
+                  <a:txBody>
+                    <a:bodyPr/>
+                    <a:lstStyle/>
+                    <a:p>
+                      <a:pPr>
+                        <a:defRPr sz="1200"/>
                       </a:pPr>
                       <a:r>
                         <a:t>June actual</a:t>
@@ -5317,7 +5341,52 @@
                     <a:lstStyle/>
                     <a:p>
                       <a:pPr>
-                        <a:defRPr sz="1400"/>
+                        <a:defRPr sz="1200"/>
+                      </a:pPr>
+                      <a:r>
+                        <a:t>0.5%</a:t>
+                      </a:r>
+                    </a:p>
+                  </a:txBody>
+                  <a:tcPr/>
+                </a:tc>
+                <a:tc>
+                  <a:txBody>
+                    <a:bodyPr/>
+                    <a:lstStyle/>
+                    <a:p>
+                      <a:pPr>
+                        <a:defRPr sz="1200"/>
+                      </a:pPr>
+                      <a:r>
+                        <a:t>9.5%</a:t>
+                      </a:r>
+                    </a:p>
+                  </a:txBody>
+                  <a:tcPr/>
+                </a:tc>
+                <a:tc>
+                  <a:txBody>
+                    <a:bodyPr/>
+                    <a:lstStyle/>
+                    <a:p>
+                      <a:pPr>
+                        <a:defRPr sz="1200"/>
+                      </a:pPr>
+                      <a:r>
+                        <a:t>42.5%</a:t>
+                      </a:r>
+                    </a:p>
+                  </a:txBody>
+                  <a:tcPr/>
+                </a:tc>
+                <a:tc>
+                  <a:txBody>
+                    <a:bodyPr/>
+                    <a:lstStyle/>
+                    <a:p>
+                      <a:pPr>
+                        <a:defRPr sz="1200"/>
                       </a:pPr>
                       <a:r>
                         <a:t>84.7%</a:t>
@@ -5326,107 +5395,92 @@
                   </a:txBody>
                   <a:tcPr/>
                 </a:tc>
-                <a:tc>
-                  <a:txBody>
-                    <a:bodyPr/>
-                    <a:lstStyle/>
-                    <a:p>
-                      <a:pPr>
-                        <a:defRPr sz="1400"/>
-                      </a:pPr>
-                      <a:r>
-                        <a:t>—</a:t>
-                      </a:r>
-                    </a:p>
-                  </a:txBody>
-                  <a:tcPr/>
-                </a:tc>
-                <a:tc>
-                  <a:txBody>
-                    <a:bodyPr/>
-                    <a:lstStyle/>
-                    <a:p>
-                      <a:pPr>
-                        <a:defRPr sz="1400"/>
-                      </a:pPr>
-                      <a:r>
-                        <a:t>—</a:t>
-                      </a:r>
-                    </a:p>
-                  </a:txBody>
-                  <a:tcPr/>
-                </a:tc>
               </a:tr>
-              <a:tr h="457200">
-                <a:tc>
-                  <a:txBody>
-                    <a:bodyPr/>
-                    <a:lstStyle/>
-                    <a:p>
-                      <a:pPr>
-                        <a:defRPr sz="1400"/>
-                      </a:pPr>
-                      <a:r>
-                        <a:t>2pm cutoff + no cushion</a:t>
-                      </a:r>
-                    </a:p>
-                  </a:txBody>
-                  <a:tcPr/>
-                </a:tc>
-                <a:tc>
-                  <a:txBody>
-                    <a:bodyPr/>
-                    <a:lstStyle/>
-                    <a:p>
-                      <a:pPr>
-                        <a:defRPr sz="1400"/>
-                      </a:pPr>
-                      <a:r>
-                        <a:t>85.9%</a:t>
-                      </a:r>
-                    </a:p>
-                  </a:txBody>
-                  <a:tcPr/>
-                </a:tc>
-                <a:tc>
-                  <a:txBody>
-                    <a:bodyPr/>
-                    <a:lstStyle/>
-                    <a:p>
-                      <a:pPr>
-                        <a:defRPr sz="1400"/>
-                      </a:pPr>
-                      <a:r>
-                        <a:t>+1.2 pp</a:t>
-                      </a:r>
-                    </a:p>
-                  </a:txBody>
-                  <a:tcPr/>
-                </a:tc>
-                <a:tc>
-                  <a:txBody>
-                    <a:bodyPr/>
-                    <a:lstStyle/>
-                    <a:p>
-                      <a:pPr>
-                        <a:defRPr sz="1400"/>
-                      </a:pPr>
-                      <a:r>
-                        <a:t>862</a:t>
+              <a:tr h="347472">
+                <a:tc>
+                  <a:txBody>
+                    <a:bodyPr/>
+                    <a:lstStyle/>
+                    <a:p>
+                      <a:pPr>
+                        <a:defRPr sz="1200"/>
+                      </a:pPr>
+                      <a:r>
+                        <a:t>2pm + no cushion</a:t>
+                      </a:r>
+                    </a:p>
+                  </a:txBody>
+                  <a:tcPr/>
+                </a:tc>
+                <a:tc>
+                  <a:txBody>
+                    <a:bodyPr/>
+                    <a:lstStyle/>
+                    <a:p>
+                      <a:pPr>
+                        <a:defRPr sz="1200"/>
+                      </a:pPr>
+                      <a:r>
+                        <a:t>5.1%</a:t>
+                      </a:r>
+                    </a:p>
+                  </a:txBody>
+                  <a:tcPr/>
+                </a:tc>
+                <a:tc>
+                  <a:txBody>
+                    <a:bodyPr/>
+                    <a:lstStyle/>
+                    <a:p>
+                      <a:pPr>
+                        <a:defRPr sz="1200"/>
+                      </a:pPr>
+                      <a:r>
+                        <a:t>24.1%</a:t>
+                      </a:r>
+                    </a:p>
+                  </a:txBody>
+                  <a:tcPr/>
+                </a:tc>
+                <a:tc>
+                  <a:txBody>
+                    <a:bodyPr/>
+                    <a:lstStyle/>
+                    <a:p>
+                      <a:pPr>
+                        <a:defRPr sz="1200"/>
+                      </a:pPr>
+                      <a:r>
+                        <a:t>55.7%</a:t>
+                      </a:r>
+                    </a:p>
+                  </a:txBody>
+                  <a:tcPr/>
+                </a:tc>
+                <a:tc>
+                  <a:txBody>
+                    <a:bodyPr/>
+                    <a:lstStyle/>
+                    <a:p>
+                      <a:pPr>
+                        <a:defRPr sz="1200"/>
+                      </a:pPr>
+                      <a:r>
+                        <a:t>85.8%</a:t>
                       </a:r>
                     </a:p>
                   </a:txBody>
                   <a:tcPr/>
                 </a:tc>
               </a:tr>
-              <a:tr h="457200">
-                <a:tc>
-                  <a:txBody>
-                    <a:bodyPr/>
-                    <a:lstStyle/>
-                    <a:p>
-                      <a:pPr>
-                        <a:defRPr sz="1400"/>
+              <a:tr h="347472">
+                <a:tc>
+                  <a:txBody>
+                    <a:bodyPr/>
+                    <a:lstStyle/>
+                    <a:p>
+                      <a:pPr>
+                        <a:defRPr sz="1200"/>
                       </a:pPr>
                       <a:r>
                         <a:t>+ Weekend shipping</a:t>
@@ -5441,7 +5495,52 @@
                     <a:lstStyle/>
                     <a:p>
                       <a:pPr>
-                        <a:defRPr sz="1400"/>
+                        <a:defRPr sz="1200"/>
+                      </a:pPr>
+                      <a:r>
+                        <a:t>6.3%</a:t>
+                      </a:r>
+                    </a:p>
+                  </a:txBody>
+                  <a:tcPr/>
+                </a:tc>
+                <a:tc>
+                  <a:txBody>
+                    <a:bodyPr/>
+                    <a:lstStyle/>
+                    <a:p>
+                      <a:pPr>
+                        <a:defRPr sz="1200"/>
+                      </a:pPr>
+                      <a:r>
+                        <a:t>26.4%</a:t>
+                      </a:r>
+                    </a:p>
+                  </a:txBody>
+                  <a:tcPr/>
+                </a:tc>
+                <a:tc>
+                  <a:txBody>
+                    <a:bodyPr/>
+                    <a:lstStyle/>
+                    <a:p>
+                      <a:pPr>
+                        <a:defRPr sz="1200"/>
+                      </a:pPr>
+                      <a:r>
+                        <a:t>59.5%</a:t>
+                      </a:r>
+                    </a:p>
+                  </a:txBody>
+                  <a:tcPr/>
+                </a:tc>
+                <a:tc>
+                  <a:txBody>
+                    <a:bodyPr/>
+                    <a:lstStyle/>
+                    <a:p>
+                      <a:pPr>
+                        <a:defRPr sz="1200"/>
                       </a:pPr>
                       <a:r>
                         <a:t>86.9%</a:t>
@@ -5450,31 +5549,94 @@
                   </a:txBody>
                   <a:tcPr/>
                 </a:tc>
-                <a:tc>
-                  <a:txBody>
-                    <a:bodyPr/>
-                    <a:lstStyle/>
-                    <a:p>
-                      <a:pPr>
-                        <a:defRPr sz="1400"/>
+              </a:tr>
+              <a:tr h="347472">
+                <a:tc>
+                  <a:txBody>
+                    <a:bodyPr/>
+                    <a:lstStyle/>
+                    <a:p>
+                      <a:pPr>
+                        <a:defRPr sz="1200"/>
+                      </a:pPr>
+                      <a:r>
+                        <a:t>Uplift (full vs June)</a:t>
+                      </a:r>
+                    </a:p>
+                  </a:txBody>
+                  <a:tcPr/>
+                </a:tc>
+                <a:tc>
+                  <a:txBody>
+                    <a:bodyPr/>
+                    <a:lstStyle/>
+                    <a:p>
+                      <a:pPr>
+                        <a:defRPr sz="1200">
+                          <a:solidFill>
+                            <a:srgbClr val="27AE60"/>
+                          </a:solidFill>
+                        </a:defRPr>
+                      </a:pPr>
+                      <a:r>
+                        <a:t>+5.8 pp</a:t>
+                      </a:r>
+                    </a:p>
+                  </a:txBody>
+                  <a:tcPr/>
+                </a:tc>
+                <a:tc>
+                  <a:txBody>
+                    <a:bodyPr/>
+                    <a:lstStyle/>
+                    <a:p>
+                      <a:pPr>
+                        <a:defRPr sz="1200">
+                          <a:solidFill>
+                            <a:srgbClr val="27AE60"/>
+                          </a:solidFill>
+                        </a:defRPr>
+                      </a:pPr>
+                      <a:r>
+                        <a:t>+17.1 pp</a:t>
+                      </a:r>
+                    </a:p>
+                  </a:txBody>
+                  <a:tcPr/>
+                </a:tc>
+                <a:tc>
+                  <a:txBody>
+                    <a:bodyPr/>
+                    <a:lstStyle/>
+                    <a:p>
+                      <a:pPr>
+                        <a:defRPr sz="1200">
+                          <a:solidFill>
+                            <a:srgbClr val="27AE60"/>
+                          </a:solidFill>
+                        </a:defRPr>
+                      </a:pPr>
+                      <a:r>
+                        <a:t>+17.0 pp</a:t>
+                      </a:r>
+                    </a:p>
+                  </a:txBody>
+                  <a:tcPr/>
+                </a:tc>
+                <a:tc>
+                  <a:txBody>
+                    <a:bodyPr/>
+                    <a:lstStyle/>
+                    <a:p>
+                      <a:pPr>
+                        <a:defRPr sz="1200">
+                          <a:solidFill>
+                            <a:srgbClr val="27AE60"/>
+                          </a:solidFill>
+                        </a:defRPr>
                       </a:pPr>
                       <a:r>
                         <a:t>+2.2 pp</a:t>
-                      </a:r>
-                    </a:p>
-                  </a:txBody>
-                  <a:tcPr/>
-                </a:tc>
-                <a:tc>
-                  <a:txBody>
-                    <a:bodyPr/>
-                    <a:lstStyle/>
-                    <a:p>
-                      <a:pPr>
-                        <a:defRPr sz="1400"/>
-                      </a:pPr>
-                      <a:r>
-                        <a:t>1,642</a:t>
                       </a:r>
                     </a:p>
                   </a:txBody>
@@ -5493,8 +5655,8 @@
         </p:nvSpPr>
         <p:spPr>
           <a:xfrm>
-            <a:off x="914400" y="3657600"/>
-            <a:ext cx="9601200" cy="2286000"/>
+            <a:off x="457200" y="3200400"/>
+            <a:ext cx="10972800" cy="1097280"/>
           </a:xfrm>
           <a:prstGeom prst="rect">
             <a:avLst/>
@@ -5515,7 +5677,42 @@
               </a:defRPr>
             </a:pPr>
             <a:r>
-              <a:t>Rules: remove cushion (−1 day) · extend cutoff to 2pm (−1 day if pre-cutoff eligible) · weekend ship Fri/Sat not inducted Sat/Sun (−1 day). Fast badge = sim O2D ≤ 5 days.</a:t>
+              <a:t>Newly badged (full sim): 4,260 · 1-day | 12,406 · 2-day | 12,479 · 3-day | 1,644 · fast</a:t>
+            </a:r>
+          </a:p>
+        </p:txBody>
+      </p:sp>
+      <p:sp>
+        <p:nvSpPr>
+          <p:cNvPr id="5" name="TextBox 4"/>
+          <p:cNvSpPr txBox="1"/>
+          <p:nvPr/>
+        </p:nvSpPr>
+        <p:spPr>
+          <a:xfrm>
+            <a:off x="457200" y="4114800"/>
+            <a:ext cx="10972800" cy="1828800"/>
+          </a:xfrm>
+          <a:prstGeom prst="rect">
+            <a:avLst/>
+          </a:prstGeom>
+          <a:noFill/>
+        </p:spPr>
+        <p:txBody>
+          <a:bodyPr wrap="square">
+            <a:spAutoFit/>
+          </a:bodyPr>
+          <a:lstStyle/>
+          <a:p>
+            <a:pPr algn="l">
+              <a:defRPr sz="1200" b="0">
+                <a:solidFill>
+                  <a:srgbClr val="333333"/>
+                </a:solidFill>
+              </a:defRPr>
+            </a:pPr>
+            <a:r>
+              <a:t>Rules: remove cushion (−1d) · 2pm cutoff (−1d) · weekend ship (−1d). Badge tier = sim O2D ≤ N days.</a:t>
             </a:r>
           </a:p>
         </p:txBody>
@@ -5603,7 +5800,7 @@
               </a:defRPr>
             </a:pPr>
             <a:r>
-              <a:t>• Zero cushion — +0.5 pp fast badge · remove LT padding in system</a:t>
+              <a:t>• Zero cushion — lifts all tiers; largest at 2- and 3-day (+~14 pp)</a:t>
             </a:r>
           </a:p>
         </p:txBody>
@@ -5638,7 +5835,7 @@
               </a:defRPr>
             </a:pPr>
             <a:r>
-              <a:t>• 2:00 PM cutoff everywhere — +0.5 pp · Easton &amp; Port Wentworth biggest uplift</a:t>
+              <a:t>• 2:00 PM cutoff everywhere — Easton &amp; Port Wentworth biggest uplift</a:t>
             </a:r>
           </a:p>
         </p:txBody>
@@ -5673,7 +5870,7 @@
               </a:defRPr>
             </a:pPr>
             <a:r>
-              <a:t>• Weekend shipping — +1.0 pp on top · Fri/Sat orders inducted Sat/Sun</a:t>
+              <a:t>• Weekend shipping — +4 pp at 3-day tier on top of policy</a:t>
             </a:r>
           </a:p>
         </p:txBody>
@@ -5708,7 +5905,7 @@
               </a:defRPr>
             </a:pPr>
             <a:r>
-              <a:t>• Combined June impact: 1,642 newly fast-badged orders</a:t>
+              <a:t>• Combined: ~12.5k newly 2-day and 3-day badged orders in June</a:t>
             </a:r>
           </a:p>
         </p:txBody>
@@ -5743,7 +5940,7 @@
               </a:defRPr>
             </a:pPr>
             <a:r>
-              <a:t>• CA nodes (Riverside/Patterson): strong induction but transit limits badge</a:t>
+              <a:t>• Fast badge (≤5d) only +2.2 pp — lead with 2/3-day story for CEO</a:t>
             </a:r>
           </a:p>
         </p:txBody>

</xml_diff>

<commit_message>
Add Safavieh performance charts and embed in slides deck
Co-authored-by: et844p <et844p@users.noreply.github.com>
</commit_message>
<xml_diff>
--- a/output/safavieh/Safavieh_CEO_June_MSBD.pptx
+++ b/output/safavieh/Safavieh_CEO_June_MSBD.pptx
@@ -14,6 +14,12 @@
     <p:sldId id="262" r:id="rId13"/>
     <p:sldId id="263" r:id="rId14"/>
     <p:sldId id="264" r:id="rId15"/>
+    <p:sldId id="265" r:id="rId16"/>
+    <p:sldId id="266" r:id="rId17"/>
+    <p:sldId id="267" r:id="rId18"/>
+    <p:sldId id="268" r:id="rId19"/>
+    <p:sldId id="269" r:id="rId20"/>
+    <p:sldId id="270" r:id="rId21"/>
   </p:sldIdLst>
   <p:sldSz cx="12191695" cy="6858000" type="screen4x3"/>
   <p:notesSz cx="6858000" cy="9144000"/>
@@ -3221,6 +3227,1402 @@
 </p:sld>
 </file>
 
+<file path=ppt/slides/slide10.xml><?xml version="1.0" encoding="utf-8"?>
+<p:sld xmlns:a="http://schemas.openxmlformats.org/drawingml/2006/main" xmlns:p="http://schemas.openxmlformats.org/presentationml/2006/main" xmlns:r="http://schemas.openxmlformats.org/officeDocument/2006/relationships">
+  <p:cSld>
+    <p:spTree>
+      <p:nvGrpSpPr>
+        <p:cNvPr id="1" name=""/>
+        <p:cNvGrpSpPr/>
+        <p:nvPr/>
+      </p:nvGrpSpPr>
+      <p:grpSpPr/>
+      <p:sp>
+        <p:nvSpPr>
+          <p:cNvPr id="2" name="TextBox 1"/>
+          <p:cNvSpPr txBox="1"/>
+          <p:nvPr/>
+        </p:nvSpPr>
+        <p:spPr>
+          <a:xfrm>
+            <a:off x="365760" y="182880"/>
+            <a:ext cx="10972800" cy="457200"/>
+          </a:xfrm>
+          <a:prstGeom prst="rect">
+            <a:avLst/>
+          </a:prstGeom>
+          <a:noFill/>
+        </p:spPr>
+        <p:txBody>
+          <a:bodyPr wrap="square">
+            <a:spAutoFit/>
+          </a:bodyPr>
+          <a:lstStyle/>
+          <a:p>
+            <a:pPr algn="l">
+              <a:defRPr sz="2000" b="1">
+                <a:solidFill>
+                  <a:srgbClr val="1A365D"/>
+                </a:solidFill>
+              </a:defRPr>
+            </a:pPr>
+            <a:r>
+              <a:t>Badging opportunity — uplift and newly badged orders</a:t>
+            </a:r>
+          </a:p>
+        </p:txBody>
+      </p:sp>
+      <p:pic>
+        <p:nvPicPr>
+          <p:cNvPr id="3" name="Picture 2" descr="05_badging_opportunity_uplift.png"/>
+          <p:cNvPicPr>
+            <a:picLocks noChangeAspect="1"/>
+          </p:cNvPicPr>
+          <p:nvPr/>
+        </p:nvPicPr>
+        <p:blipFill>
+          <a:blip r:embed="rId2"/>
+          <a:stretch>
+            <a:fillRect/>
+          </a:stretch>
+        </p:blipFill>
+        <p:spPr>
+          <a:xfrm>
+            <a:off x="320040" y="685800"/>
+            <a:ext cx="11521440" cy="4991331"/>
+          </a:xfrm>
+          <a:prstGeom prst="rect">
+            <a:avLst/>
+          </a:prstGeom>
+        </p:spPr>
+      </p:pic>
+    </p:spTree>
+  </p:cSld>
+  <p:clrMapOvr>
+    <a:masterClrMapping/>
+  </p:clrMapOvr>
+</p:sld>
+</file>
+
+<file path=ppt/slides/slide11.xml><?xml version="1.0" encoding="utf-8"?>
+<p:sld xmlns:a="http://schemas.openxmlformats.org/drawingml/2006/main" xmlns:p="http://schemas.openxmlformats.org/presentationml/2006/main" xmlns:r="http://schemas.openxmlformats.org/officeDocument/2006/relationships">
+  <p:cSld>
+    <p:spTree>
+      <p:nvGrpSpPr>
+        <p:cNvPr id="1" name=""/>
+        <p:cNvGrpSpPr/>
+        <p:nvPr/>
+      </p:nvGrpSpPr>
+      <p:grpSpPr/>
+      <p:sp>
+        <p:nvSpPr>
+          <p:cNvPr id="2" name="TextBox 1"/>
+          <p:cNvSpPr txBox="1"/>
+          <p:nvPr/>
+        </p:nvSpPr>
+        <p:spPr>
+          <a:xfrm>
+            <a:off x="365760" y="182880"/>
+            <a:ext cx="10972800" cy="457200"/>
+          </a:xfrm>
+          <a:prstGeom prst="rect">
+            <a:avLst/>
+          </a:prstGeom>
+          <a:noFill/>
+        </p:spPr>
+        <p:txBody>
+          <a:bodyPr wrap="square">
+            <a:spAutoFit/>
+          </a:bodyPr>
+          <a:lstStyle/>
+          <a:p>
+            <a:pPr algn="l">
+              <a:defRPr sz="2000" b="1">
+                <a:solidFill>
+                  <a:srgbClr val="1A365D"/>
+                </a:solidFill>
+              </a:defRPr>
+            </a:pPr>
+            <a:r>
+              <a:t>3-day badge by warehouse — current vs simulated</a:t>
+            </a:r>
+          </a:p>
+        </p:txBody>
+      </p:sp>
+      <p:pic>
+        <p:nvPicPr>
+          <p:cNvPr id="3" name="Picture 2" descr="06_3d_badge_by_warehouse.png"/>
+          <p:cNvPicPr>
+            <a:picLocks noChangeAspect="1"/>
+          </p:cNvPicPr>
+          <p:nvPr/>
+        </p:nvPicPr>
+        <p:blipFill>
+          <a:blip r:embed="rId2"/>
+          <a:stretch>
+            <a:fillRect/>
+          </a:stretch>
+        </p:blipFill>
+        <p:spPr>
+          <a:xfrm>
+            <a:off x="320040" y="685800"/>
+            <a:ext cx="11521440" cy="6881725"/>
+          </a:xfrm>
+          <a:prstGeom prst="rect">
+            <a:avLst/>
+          </a:prstGeom>
+        </p:spPr>
+      </p:pic>
+    </p:spTree>
+  </p:cSld>
+  <p:clrMapOvr>
+    <a:masterClrMapping/>
+  </p:clrMapOvr>
+</p:sld>
+</file>
+
+<file path=ppt/slides/slide12.xml><?xml version="1.0" encoding="utf-8"?>
+<p:sld xmlns:a="http://schemas.openxmlformats.org/drawingml/2006/main" xmlns:p="http://schemas.openxmlformats.org/presentationml/2006/main" xmlns:r="http://schemas.openxmlformats.org/officeDocument/2006/relationships">
+  <p:cSld>
+    <p:spTree>
+      <p:nvGrpSpPr>
+        <p:cNvPr id="1" name=""/>
+        <p:cNvGrpSpPr/>
+        <p:nvPr/>
+      </p:nvGrpSpPr>
+      <p:grpSpPr/>
+      <p:sp>
+        <p:nvSpPr>
+          <p:cNvPr id="2" name="TextBox 1"/>
+          <p:cNvSpPr txBox="1"/>
+          <p:nvPr/>
+        </p:nvSpPr>
+        <p:spPr>
+          <a:xfrm>
+            <a:off x="365760" y="228600"/>
+            <a:ext cx="10972800" cy="548640"/>
+          </a:xfrm>
+          <a:prstGeom prst="rect">
+            <a:avLst/>
+          </a:prstGeom>
+          <a:noFill/>
+        </p:spPr>
+        <p:txBody>
+          <a:bodyPr wrap="square">
+            <a:spAutoFit/>
+          </a:bodyPr>
+          <a:lstStyle/>
+          <a:p>
+            <a:pPr algn="l">
+              <a:defRPr sz="2400" b="1">
+                <a:solidFill>
+                  <a:srgbClr val="1A365D"/>
+                </a:solidFill>
+              </a:defRPr>
+            </a:pPr>
+            <a:r>
+              <a:t>Badging simulation — all speed tiers (June MSBD)</a:t>
+            </a:r>
+          </a:p>
+        </p:txBody>
+      </p:sp>
+      <p:graphicFrame>
+        <p:nvGraphicFramePr>
+          <p:cNvPr id="3" name="Table 2"/>
+          <p:cNvGraphicFramePr>
+            <a:graphicFrameLocks noGrp="1"/>
+          </p:cNvGraphicFramePr>
+          <p:nvPr/>
+        </p:nvGraphicFramePr>
+        <p:xfrm>
+          <a:off x="457200" y="914400"/>
+          <a:ext cx="11247120" cy="1737360"/>
+        </p:xfrm>
+        <a:graphic>
+          <a:graphicData uri="http://schemas.openxmlformats.org/drawingml/2006/table">
+            <a:tbl>
+              <a:tblPr firstRow="1" bandRow="1">
+                <a:tableStyleId>{5C22544A-7EE6-4342-B048-85BDC9FD1C3A}</a:tableStyleId>
+              </a:tblPr>
+              <a:tblGrid>
+                <a:gridCol w="2249424"/>
+                <a:gridCol w="2249424"/>
+                <a:gridCol w="2249424"/>
+                <a:gridCol w="2249424"/>
+                <a:gridCol w="2249424"/>
+              </a:tblGrid>
+              <a:tr h="347472">
+                <a:tc>
+                  <a:txBody>
+                    <a:bodyPr/>
+                    <a:lstStyle/>
+                    <a:p>
+                      <a:pPr>
+                        <a:defRPr b="1" sz="1200">
+                          <a:solidFill>
+                            <a:srgbClr val="FFFFFF"/>
+                          </a:solidFill>
+                        </a:defRPr>
+                      </a:pPr>
+                      <a:r>
+                        <a:t>Scenario</a:t>
+                      </a:r>
+                    </a:p>
+                  </a:txBody>
+                  <a:tcPr>
+                    <a:solidFill>
+                      <a:srgbClr val="1A365D"/>
+                    </a:solidFill>
+                  </a:tcPr>
+                </a:tc>
+                <a:tc>
+                  <a:txBody>
+                    <a:bodyPr/>
+                    <a:lstStyle/>
+                    <a:p>
+                      <a:pPr>
+                        <a:defRPr b="1" sz="1200">
+                          <a:solidFill>
+                            <a:srgbClr val="FFFFFF"/>
+                          </a:solidFill>
+                        </a:defRPr>
+                      </a:pPr>
+                      <a:r>
+                        <a:t>1-day</a:t>
+                      </a:r>
+                    </a:p>
+                  </a:txBody>
+                  <a:tcPr>
+                    <a:solidFill>
+                      <a:srgbClr val="1A365D"/>
+                    </a:solidFill>
+                  </a:tcPr>
+                </a:tc>
+                <a:tc>
+                  <a:txBody>
+                    <a:bodyPr/>
+                    <a:lstStyle/>
+                    <a:p>
+                      <a:pPr>
+                        <a:defRPr b="1" sz="1200">
+                          <a:solidFill>
+                            <a:srgbClr val="FFFFFF"/>
+                          </a:solidFill>
+                        </a:defRPr>
+                      </a:pPr>
+                      <a:r>
+                        <a:t>2-day</a:t>
+                      </a:r>
+                    </a:p>
+                  </a:txBody>
+                  <a:tcPr>
+                    <a:solidFill>
+                      <a:srgbClr val="1A365D"/>
+                    </a:solidFill>
+                  </a:tcPr>
+                </a:tc>
+                <a:tc>
+                  <a:txBody>
+                    <a:bodyPr/>
+                    <a:lstStyle/>
+                    <a:p>
+                      <a:pPr>
+                        <a:defRPr b="1" sz="1200">
+                          <a:solidFill>
+                            <a:srgbClr val="FFFFFF"/>
+                          </a:solidFill>
+                        </a:defRPr>
+                      </a:pPr>
+                      <a:r>
+                        <a:t>3-day</a:t>
+                      </a:r>
+                    </a:p>
+                  </a:txBody>
+                  <a:tcPr>
+                    <a:solidFill>
+                      <a:srgbClr val="1A365D"/>
+                    </a:solidFill>
+                  </a:tcPr>
+                </a:tc>
+                <a:tc>
+                  <a:txBody>
+                    <a:bodyPr/>
+                    <a:lstStyle/>
+                    <a:p>
+                      <a:pPr>
+                        <a:defRPr b="1" sz="1200">
+                          <a:solidFill>
+                            <a:srgbClr val="FFFFFF"/>
+                          </a:solidFill>
+                        </a:defRPr>
+                      </a:pPr>
+                      <a:r>
+                        <a:t>Fast ≤5d</a:t>
+                      </a:r>
+                    </a:p>
+                  </a:txBody>
+                  <a:tcPr>
+                    <a:solidFill>
+                      <a:srgbClr val="1A365D"/>
+                    </a:solidFill>
+                  </a:tcPr>
+                </a:tc>
+              </a:tr>
+              <a:tr h="347472">
+                <a:tc>
+                  <a:txBody>
+                    <a:bodyPr/>
+                    <a:lstStyle/>
+                    <a:p>
+                      <a:pPr>
+                        <a:defRPr sz="1200"/>
+                      </a:pPr>
+                      <a:r>
+                        <a:t>June actual</a:t>
+                      </a:r>
+                    </a:p>
+                  </a:txBody>
+                  <a:tcPr/>
+                </a:tc>
+                <a:tc>
+                  <a:txBody>
+                    <a:bodyPr/>
+                    <a:lstStyle/>
+                    <a:p>
+                      <a:pPr>
+                        <a:defRPr sz="1200"/>
+                      </a:pPr>
+                      <a:r>
+                        <a:t>0.5%</a:t>
+                      </a:r>
+                    </a:p>
+                  </a:txBody>
+                  <a:tcPr/>
+                </a:tc>
+                <a:tc>
+                  <a:txBody>
+                    <a:bodyPr/>
+                    <a:lstStyle/>
+                    <a:p>
+                      <a:pPr>
+                        <a:defRPr sz="1200"/>
+                      </a:pPr>
+                      <a:r>
+                        <a:t>9.5%</a:t>
+                      </a:r>
+                    </a:p>
+                  </a:txBody>
+                  <a:tcPr/>
+                </a:tc>
+                <a:tc>
+                  <a:txBody>
+                    <a:bodyPr/>
+                    <a:lstStyle/>
+                    <a:p>
+                      <a:pPr>
+                        <a:defRPr sz="1200"/>
+                      </a:pPr>
+                      <a:r>
+                        <a:t>42.5%</a:t>
+                      </a:r>
+                    </a:p>
+                  </a:txBody>
+                  <a:tcPr/>
+                </a:tc>
+                <a:tc>
+                  <a:txBody>
+                    <a:bodyPr/>
+                    <a:lstStyle/>
+                    <a:p>
+                      <a:pPr>
+                        <a:defRPr sz="1200"/>
+                      </a:pPr>
+                      <a:r>
+                        <a:t>84.7%</a:t>
+                      </a:r>
+                    </a:p>
+                  </a:txBody>
+                  <a:tcPr/>
+                </a:tc>
+              </a:tr>
+              <a:tr h="347472">
+                <a:tc>
+                  <a:txBody>
+                    <a:bodyPr/>
+                    <a:lstStyle/>
+                    <a:p>
+                      <a:pPr>
+                        <a:defRPr sz="1200"/>
+                      </a:pPr>
+                      <a:r>
+                        <a:t>2pm + no cushion</a:t>
+                      </a:r>
+                    </a:p>
+                  </a:txBody>
+                  <a:tcPr/>
+                </a:tc>
+                <a:tc>
+                  <a:txBody>
+                    <a:bodyPr/>
+                    <a:lstStyle/>
+                    <a:p>
+                      <a:pPr>
+                        <a:defRPr sz="1200"/>
+                      </a:pPr>
+                      <a:r>
+                        <a:t>5.1%</a:t>
+                      </a:r>
+                    </a:p>
+                  </a:txBody>
+                  <a:tcPr/>
+                </a:tc>
+                <a:tc>
+                  <a:txBody>
+                    <a:bodyPr/>
+                    <a:lstStyle/>
+                    <a:p>
+                      <a:pPr>
+                        <a:defRPr sz="1200"/>
+                      </a:pPr>
+                      <a:r>
+                        <a:t>24.1%</a:t>
+                      </a:r>
+                    </a:p>
+                  </a:txBody>
+                  <a:tcPr/>
+                </a:tc>
+                <a:tc>
+                  <a:txBody>
+                    <a:bodyPr/>
+                    <a:lstStyle/>
+                    <a:p>
+                      <a:pPr>
+                        <a:defRPr sz="1200"/>
+                      </a:pPr>
+                      <a:r>
+                        <a:t>55.7%</a:t>
+                      </a:r>
+                    </a:p>
+                  </a:txBody>
+                  <a:tcPr/>
+                </a:tc>
+                <a:tc>
+                  <a:txBody>
+                    <a:bodyPr/>
+                    <a:lstStyle/>
+                    <a:p>
+                      <a:pPr>
+                        <a:defRPr sz="1200"/>
+                      </a:pPr>
+                      <a:r>
+                        <a:t>85.8%</a:t>
+                      </a:r>
+                    </a:p>
+                  </a:txBody>
+                  <a:tcPr/>
+                </a:tc>
+              </a:tr>
+              <a:tr h="347472">
+                <a:tc>
+                  <a:txBody>
+                    <a:bodyPr/>
+                    <a:lstStyle/>
+                    <a:p>
+                      <a:pPr>
+                        <a:defRPr sz="1200"/>
+                      </a:pPr>
+                      <a:r>
+                        <a:t>+ Weekend shipping</a:t>
+                      </a:r>
+                    </a:p>
+                  </a:txBody>
+                  <a:tcPr/>
+                </a:tc>
+                <a:tc>
+                  <a:txBody>
+                    <a:bodyPr/>
+                    <a:lstStyle/>
+                    <a:p>
+                      <a:pPr>
+                        <a:defRPr sz="1200"/>
+                      </a:pPr>
+                      <a:r>
+                        <a:t>6.3%</a:t>
+                      </a:r>
+                    </a:p>
+                  </a:txBody>
+                  <a:tcPr/>
+                </a:tc>
+                <a:tc>
+                  <a:txBody>
+                    <a:bodyPr/>
+                    <a:lstStyle/>
+                    <a:p>
+                      <a:pPr>
+                        <a:defRPr sz="1200"/>
+                      </a:pPr>
+                      <a:r>
+                        <a:t>26.4%</a:t>
+                      </a:r>
+                    </a:p>
+                  </a:txBody>
+                  <a:tcPr/>
+                </a:tc>
+                <a:tc>
+                  <a:txBody>
+                    <a:bodyPr/>
+                    <a:lstStyle/>
+                    <a:p>
+                      <a:pPr>
+                        <a:defRPr sz="1200"/>
+                      </a:pPr>
+                      <a:r>
+                        <a:t>59.5%</a:t>
+                      </a:r>
+                    </a:p>
+                  </a:txBody>
+                  <a:tcPr/>
+                </a:tc>
+                <a:tc>
+                  <a:txBody>
+                    <a:bodyPr/>
+                    <a:lstStyle/>
+                    <a:p>
+                      <a:pPr>
+                        <a:defRPr sz="1200"/>
+                      </a:pPr>
+                      <a:r>
+                        <a:t>86.9%</a:t>
+                      </a:r>
+                    </a:p>
+                  </a:txBody>
+                  <a:tcPr/>
+                </a:tc>
+              </a:tr>
+              <a:tr h="347472">
+                <a:tc>
+                  <a:txBody>
+                    <a:bodyPr/>
+                    <a:lstStyle/>
+                    <a:p>
+                      <a:pPr>
+                        <a:defRPr sz="1200"/>
+                      </a:pPr>
+                      <a:r>
+                        <a:t>Uplift (full vs June)</a:t>
+                      </a:r>
+                    </a:p>
+                  </a:txBody>
+                  <a:tcPr/>
+                </a:tc>
+                <a:tc>
+                  <a:txBody>
+                    <a:bodyPr/>
+                    <a:lstStyle/>
+                    <a:p>
+                      <a:pPr>
+                        <a:defRPr sz="1200">
+                          <a:solidFill>
+                            <a:srgbClr val="27AE60"/>
+                          </a:solidFill>
+                        </a:defRPr>
+                      </a:pPr>
+                      <a:r>
+                        <a:t>+5.8 pp</a:t>
+                      </a:r>
+                    </a:p>
+                  </a:txBody>
+                  <a:tcPr/>
+                </a:tc>
+                <a:tc>
+                  <a:txBody>
+                    <a:bodyPr/>
+                    <a:lstStyle/>
+                    <a:p>
+                      <a:pPr>
+                        <a:defRPr sz="1200">
+                          <a:solidFill>
+                            <a:srgbClr val="27AE60"/>
+                          </a:solidFill>
+                        </a:defRPr>
+                      </a:pPr>
+                      <a:r>
+                        <a:t>+17.1 pp</a:t>
+                      </a:r>
+                    </a:p>
+                  </a:txBody>
+                  <a:tcPr/>
+                </a:tc>
+                <a:tc>
+                  <a:txBody>
+                    <a:bodyPr/>
+                    <a:lstStyle/>
+                    <a:p>
+                      <a:pPr>
+                        <a:defRPr sz="1200">
+                          <a:solidFill>
+                            <a:srgbClr val="27AE60"/>
+                          </a:solidFill>
+                        </a:defRPr>
+                      </a:pPr>
+                      <a:r>
+                        <a:t>+17.0 pp</a:t>
+                      </a:r>
+                    </a:p>
+                  </a:txBody>
+                  <a:tcPr/>
+                </a:tc>
+                <a:tc>
+                  <a:txBody>
+                    <a:bodyPr/>
+                    <a:lstStyle/>
+                    <a:p>
+                      <a:pPr>
+                        <a:defRPr sz="1200">
+                          <a:solidFill>
+                            <a:srgbClr val="27AE60"/>
+                          </a:solidFill>
+                        </a:defRPr>
+                      </a:pPr>
+                      <a:r>
+                        <a:t>+2.2 pp</a:t>
+                      </a:r>
+                    </a:p>
+                  </a:txBody>
+                  <a:tcPr/>
+                </a:tc>
+              </a:tr>
+            </a:tbl>
+          </a:graphicData>
+        </a:graphic>
+      </p:graphicFrame>
+      <p:sp>
+        <p:nvSpPr>
+          <p:cNvPr id="4" name="TextBox 3"/>
+          <p:cNvSpPr txBox="1"/>
+          <p:nvPr/>
+        </p:nvSpPr>
+        <p:spPr>
+          <a:xfrm>
+            <a:off x="457200" y="3200400"/>
+            <a:ext cx="10972800" cy="1097280"/>
+          </a:xfrm>
+          <a:prstGeom prst="rect">
+            <a:avLst/>
+          </a:prstGeom>
+          <a:noFill/>
+        </p:spPr>
+        <p:txBody>
+          <a:bodyPr wrap="square">
+            <a:spAutoFit/>
+          </a:bodyPr>
+          <a:lstStyle/>
+          <a:p>
+            <a:pPr algn="l">
+              <a:defRPr sz="1300" b="0">
+                <a:solidFill>
+                  <a:srgbClr val="333333"/>
+                </a:solidFill>
+              </a:defRPr>
+            </a:pPr>
+            <a:r>
+              <a:t>Newly badged (full sim): 4,260 · 1-day | 12,406 · 2-day | 12,479 · 3-day | 1,644 · fast</a:t>
+            </a:r>
+          </a:p>
+        </p:txBody>
+      </p:sp>
+      <p:sp>
+        <p:nvSpPr>
+          <p:cNvPr id="5" name="TextBox 4"/>
+          <p:cNvSpPr txBox="1"/>
+          <p:nvPr/>
+        </p:nvSpPr>
+        <p:spPr>
+          <a:xfrm>
+            <a:off x="457200" y="4114800"/>
+            <a:ext cx="10972800" cy="1828800"/>
+          </a:xfrm>
+          <a:prstGeom prst="rect">
+            <a:avLst/>
+          </a:prstGeom>
+          <a:noFill/>
+        </p:spPr>
+        <p:txBody>
+          <a:bodyPr wrap="square">
+            <a:spAutoFit/>
+          </a:bodyPr>
+          <a:lstStyle/>
+          <a:p>
+            <a:pPr algn="l">
+              <a:defRPr sz="1200" b="0">
+                <a:solidFill>
+                  <a:srgbClr val="333333"/>
+                </a:solidFill>
+              </a:defRPr>
+            </a:pPr>
+            <a:r>
+              <a:t>Rules: remove cushion (−1d) · 2pm cutoff (−1d) · weekend ship (−1d). Badge tier = sim O2D ≤ N days.</a:t>
+            </a:r>
+          </a:p>
+        </p:txBody>
+      </p:sp>
+    </p:spTree>
+  </p:cSld>
+  <p:clrMapOvr>
+    <a:masterClrMapping/>
+  </p:clrMapOvr>
+</p:sld>
+</file>
+
+<file path=ppt/slides/slide13.xml><?xml version="1.0" encoding="utf-8"?>
+<p:sld xmlns:a="http://schemas.openxmlformats.org/drawingml/2006/main" xmlns:p="http://schemas.openxmlformats.org/presentationml/2006/main" xmlns:r="http://schemas.openxmlformats.org/officeDocument/2006/relationships">
+  <p:cSld>
+    <p:spTree>
+      <p:nvGrpSpPr>
+        <p:cNvPr id="1" name=""/>
+        <p:cNvGrpSpPr/>
+        <p:nvPr/>
+      </p:nvGrpSpPr>
+      <p:grpSpPr/>
+      <p:sp>
+        <p:nvSpPr>
+          <p:cNvPr id="2" name="TextBox 1"/>
+          <p:cNvSpPr txBox="1"/>
+          <p:nvPr/>
+        </p:nvSpPr>
+        <p:spPr>
+          <a:xfrm>
+            <a:off x="548640" y="365760"/>
+            <a:ext cx="10972800" cy="731520"/>
+          </a:xfrm>
+          <a:prstGeom prst="rect">
+            <a:avLst/>
+          </a:prstGeom>
+          <a:noFill/>
+        </p:spPr>
+        <p:txBody>
+          <a:bodyPr wrap="square">
+            <a:spAutoFit/>
+          </a:bodyPr>
+          <a:lstStyle/>
+          <a:p>
+            <a:pPr algn="l">
+              <a:defRPr sz="2800" b="1">
+                <a:solidFill>
+                  <a:srgbClr val="1A365D"/>
+                </a:solidFill>
+              </a:defRPr>
+            </a:pPr>
+            <a:r>
+              <a:t>Three policy levers</a:t>
+            </a:r>
+          </a:p>
+        </p:txBody>
+      </p:sp>
+      <p:sp>
+        <p:nvSpPr>
+          <p:cNvPr id="3" name="TextBox 2"/>
+          <p:cNvSpPr txBox="1"/>
+          <p:nvPr/>
+        </p:nvSpPr>
+        <p:spPr>
+          <a:xfrm>
+            <a:off x="731520" y="1188720"/>
+            <a:ext cx="10515600" cy="502920"/>
+          </a:xfrm>
+          <a:prstGeom prst="rect">
+            <a:avLst/>
+          </a:prstGeom>
+          <a:noFill/>
+        </p:spPr>
+        <p:txBody>
+          <a:bodyPr wrap="square">
+            <a:spAutoFit/>
+          </a:bodyPr>
+          <a:lstStyle/>
+          <a:p>
+            <a:pPr algn="l">
+              <a:defRPr sz="1600" b="0">
+                <a:solidFill>
+                  <a:srgbClr val="333333"/>
+                </a:solidFill>
+              </a:defRPr>
+            </a:pPr>
+            <a:r>
+              <a:t>• Zero cushion — lifts all tiers; largest at 2- and 3-day (+~14 pp)</a:t>
+            </a:r>
+          </a:p>
+        </p:txBody>
+      </p:sp>
+      <p:sp>
+        <p:nvSpPr>
+          <p:cNvPr id="4" name="TextBox 3"/>
+          <p:cNvSpPr txBox="1"/>
+          <p:nvPr/>
+        </p:nvSpPr>
+        <p:spPr>
+          <a:xfrm>
+            <a:off x="731520" y="1645920"/>
+            <a:ext cx="10515600" cy="502920"/>
+          </a:xfrm>
+          <a:prstGeom prst="rect">
+            <a:avLst/>
+          </a:prstGeom>
+          <a:noFill/>
+        </p:spPr>
+        <p:txBody>
+          <a:bodyPr wrap="square">
+            <a:spAutoFit/>
+          </a:bodyPr>
+          <a:lstStyle/>
+          <a:p>
+            <a:pPr algn="l">
+              <a:defRPr sz="1600" b="0">
+                <a:solidFill>
+                  <a:srgbClr val="333333"/>
+                </a:solidFill>
+              </a:defRPr>
+            </a:pPr>
+            <a:r>
+              <a:t>• 2:00 PM cutoff everywhere — Easton &amp; Port Wentworth biggest uplift</a:t>
+            </a:r>
+          </a:p>
+        </p:txBody>
+      </p:sp>
+      <p:sp>
+        <p:nvSpPr>
+          <p:cNvPr id="5" name="TextBox 4"/>
+          <p:cNvSpPr txBox="1"/>
+          <p:nvPr/>
+        </p:nvSpPr>
+        <p:spPr>
+          <a:xfrm>
+            <a:off x="731520" y="2103120"/>
+            <a:ext cx="10515600" cy="502920"/>
+          </a:xfrm>
+          <a:prstGeom prst="rect">
+            <a:avLst/>
+          </a:prstGeom>
+          <a:noFill/>
+        </p:spPr>
+        <p:txBody>
+          <a:bodyPr wrap="square">
+            <a:spAutoFit/>
+          </a:bodyPr>
+          <a:lstStyle/>
+          <a:p>
+            <a:pPr algn="l">
+              <a:defRPr sz="1600" b="0">
+                <a:solidFill>
+                  <a:srgbClr val="333333"/>
+                </a:solidFill>
+              </a:defRPr>
+            </a:pPr>
+            <a:r>
+              <a:t>• Weekend shipping — +4 pp at 3-day tier on top of policy</a:t>
+            </a:r>
+          </a:p>
+        </p:txBody>
+      </p:sp>
+      <p:sp>
+        <p:nvSpPr>
+          <p:cNvPr id="6" name="TextBox 5"/>
+          <p:cNvSpPr txBox="1"/>
+          <p:nvPr/>
+        </p:nvSpPr>
+        <p:spPr>
+          <a:xfrm>
+            <a:off x="731520" y="2560320"/>
+            <a:ext cx="10515600" cy="502920"/>
+          </a:xfrm>
+          <a:prstGeom prst="rect">
+            <a:avLst/>
+          </a:prstGeom>
+          <a:noFill/>
+        </p:spPr>
+        <p:txBody>
+          <a:bodyPr wrap="square">
+            <a:spAutoFit/>
+          </a:bodyPr>
+          <a:lstStyle/>
+          <a:p>
+            <a:pPr algn="l">
+              <a:defRPr sz="1600" b="0">
+                <a:solidFill>
+                  <a:srgbClr val="333333"/>
+                </a:solidFill>
+              </a:defRPr>
+            </a:pPr>
+            <a:r>
+              <a:t>• Combined: ~12.5k newly 2-day and 3-day badged orders in June</a:t>
+            </a:r>
+          </a:p>
+        </p:txBody>
+      </p:sp>
+      <p:sp>
+        <p:nvSpPr>
+          <p:cNvPr id="7" name="TextBox 6"/>
+          <p:cNvSpPr txBox="1"/>
+          <p:nvPr/>
+        </p:nvSpPr>
+        <p:spPr>
+          <a:xfrm>
+            <a:off x="731520" y="3017520"/>
+            <a:ext cx="10515600" cy="502920"/>
+          </a:xfrm>
+          <a:prstGeom prst="rect">
+            <a:avLst/>
+          </a:prstGeom>
+          <a:noFill/>
+        </p:spPr>
+        <p:txBody>
+          <a:bodyPr wrap="square">
+            <a:spAutoFit/>
+          </a:bodyPr>
+          <a:lstStyle/>
+          <a:p>
+            <a:pPr algn="l">
+              <a:defRPr sz="1600" b="0">
+                <a:solidFill>
+                  <a:srgbClr val="333333"/>
+                </a:solidFill>
+              </a:defRPr>
+            </a:pPr>
+            <a:r>
+              <a:t>• Fast badge (≤5d) only +2.2 pp — lead with 2/3-day story for CEO</a:t>
+            </a:r>
+          </a:p>
+        </p:txBody>
+      </p:sp>
+    </p:spTree>
+  </p:cSld>
+  <p:clrMapOvr>
+    <a:masterClrMapping/>
+  </p:clrMapOvr>
+</p:sld>
+</file>
+
+<file path=ppt/slides/slide14.xml><?xml version="1.0" encoding="utf-8"?>
+<p:sld xmlns:a="http://schemas.openxmlformats.org/drawingml/2006/main" xmlns:p="http://schemas.openxmlformats.org/presentationml/2006/main" xmlns:r="http://schemas.openxmlformats.org/officeDocument/2006/relationships">
+  <p:cSld>
+    <p:spTree>
+      <p:nvGrpSpPr>
+        <p:cNvPr id="1" name=""/>
+        <p:cNvGrpSpPr/>
+        <p:nvPr/>
+      </p:nvGrpSpPr>
+      <p:grpSpPr/>
+      <p:sp>
+        <p:nvSpPr>
+          <p:cNvPr id="2" name="TextBox 1"/>
+          <p:cNvSpPr txBox="1"/>
+          <p:nvPr/>
+        </p:nvSpPr>
+        <p:spPr>
+          <a:xfrm>
+            <a:off x="548640" y="365760"/>
+            <a:ext cx="10972800" cy="731520"/>
+          </a:xfrm>
+          <a:prstGeom prst="rect">
+            <a:avLst/>
+          </a:prstGeom>
+          <a:noFill/>
+        </p:spPr>
+        <p:txBody>
+          <a:bodyPr wrap="square">
+            <a:spAutoFit/>
+          </a:bodyPr>
+          <a:lstStyle/>
+          <a:p>
+            <a:pPr algn="l">
+              <a:defRPr sz="2800" b="1">
+                <a:solidFill>
+                  <a:srgbClr val="1A365D"/>
+                </a:solidFill>
+              </a:defRPr>
+            </a:pPr>
+            <a:r>
+              <a:t>Discussion questions for the CEO</a:t>
+            </a:r>
+          </a:p>
+        </p:txBody>
+      </p:sp>
+      <p:sp>
+        <p:nvSpPr>
+          <p:cNvPr id="3" name="TextBox 2"/>
+          <p:cNvSpPr txBox="1"/>
+          <p:nvPr/>
+        </p:nvSpPr>
+        <p:spPr>
+          <a:xfrm>
+            <a:off x="731520" y="1188720"/>
+            <a:ext cx="10515600" cy="502920"/>
+          </a:xfrm>
+          <a:prstGeom prst="rect">
+            <a:avLst/>
+          </a:prstGeom>
+          <a:noFill/>
+        </p:spPr>
+        <p:txBody>
+          <a:bodyPr wrap="square">
+            <a:spAutoFit/>
+          </a:bodyPr>
+          <a:lstStyle/>
+          <a:p>
+            <a:pPr algn="l">
+              <a:defRPr sz="1600" b="0">
+                <a:solidFill>
+                  <a:srgbClr val="333333"/>
+                </a:solidFill>
+              </a:defRPr>
+            </a:pPr>
+            <a:r>
+              <a:t>• Can every DC match Carlisle's 94% same-day induction before 2pm?</a:t>
+            </a:r>
+          </a:p>
+        </p:txBody>
+      </p:sp>
+      <p:sp>
+        <p:nvSpPr>
+          <p:cNvPr id="4" name="TextBox 3"/>
+          <p:cNvSpPr txBox="1"/>
+          <p:nvPr/>
+        </p:nvSpPr>
+        <p:spPr>
+          <a:xfrm>
+            <a:off x="731520" y="1645920"/>
+            <a:ext cx="10515600" cy="502920"/>
+          </a:xfrm>
+          <a:prstGeom prst="rect">
+            <a:avLst/>
+          </a:prstGeom>
+          <a:noFill/>
+        </p:spPr>
+        <p:txBody>
+          <a:bodyPr wrap="square">
+            <a:spAutoFit/>
+          </a:bodyPr>
+          <a:lstStyle/>
+          <a:p>
+            <a:pPr algn="l">
+              <a:defRPr sz="1600" b="0">
+                <a:solidFill>
+                  <a:srgbClr val="333333"/>
+                </a:solidFill>
+              </a:defRPr>
+            </a:pPr>
+            <a:r>
+              <a:t>• Will Safavieh standardize 2:00 PM cutoff and zero cushion network-wide?</a:t>
+            </a:r>
+          </a:p>
+        </p:txBody>
+      </p:sp>
+      <p:sp>
+        <p:nvSpPr>
+          <p:cNvPr id="5" name="TextBox 4"/>
+          <p:cNvSpPr txBox="1"/>
+          <p:nvPr/>
+        </p:nvSpPr>
+        <p:spPr>
+          <a:xfrm>
+            <a:off x="731520" y="2103120"/>
+            <a:ext cx="10515600" cy="502920"/>
+          </a:xfrm>
+          <a:prstGeom prst="rect">
+            <a:avLst/>
+          </a:prstGeom>
+          <a:noFill/>
+        </p:spPr>
+        <p:txBody>
+          <a:bodyPr wrap="square">
+            <a:spAutoFit/>
+          </a:bodyPr>
+          <a:lstStyle/>
+          <a:p>
+            <a:pPr algn="l">
+              <a:defRPr sz="1600" b="0">
+                <a:solidFill>
+                  <a:srgbClr val="333333"/>
+                </a:solidFill>
+              </a:defRPr>
+            </a:pPr>
+            <a:r>
+              <a:t>• Is weekend shipping feasible at NJ and PA nodes?</a:t>
+            </a:r>
+          </a:p>
+        </p:txBody>
+      </p:sp>
+      <p:sp>
+        <p:nvSpPr>
+          <p:cNvPr id="6" name="TextBox 5"/>
+          <p:cNvSpPr txBox="1"/>
+          <p:nvPr/>
+        </p:nvSpPr>
+        <p:spPr>
+          <a:xfrm>
+            <a:off x="731520" y="2560320"/>
+            <a:ext cx="10515600" cy="502920"/>
+          </a:xfrm>
+          <a:prstGeom prst="rect">
+            <a:avLst/>
+          </a:prstGeom>
+          <a:noFill/>
+        </p:spPr>
+        <p:txBody>
+          <a:bodyPr wrap="square">
+            <a:spAutoFit/>
+          </a:bodyPr>
+          <a:lstStyle/>
+          <a:p>
+            <a:pPr algn="l">
+              <a:defRPr sz="1600" b="0">
+                <a:solidFill>
+                  <a:srgbClr val="333333"/>
+                </a:solidFill>
+              </a:defRPr>
+            </a:pPr>
+            <a:r>
+              <a:t>• What FedEx pickup schedule runs at Easton, Lebanon, Port Wentworth today?</a:t>
+            </a:r>
+          </a:p>
+        </p:txBody>
+      </p:sp>
+      <p:sp>
+        <p:nvSpPr>
+          <p:cNvPr id="7" name="TextBox 6"/>
+          <p:cNvSpPr txBox="1"/>
+          <p:nvPr/>
+        </p:nvSpPr>
+        <p:spPr>
+          <a:xfrm>
+            <a:off x="731520" y="3017520"/>
+            <a:ext cx="10515600" cy="502920"/>
+          </a:xfrm>
+          <a:prstGeom prst="rect">
+            <a:avLst/>
+          </a:prstGeom>
+          <a:noFill/>
+        </p:spPr>
+        <p:txBody>
+          <a:bodyPr wrap="square">
+            <a:spAutoFit/>
+          </a:bodyPr>
+          <a:lstStyle/>
+          <a:p>
+            <a:pPr algn="l">
+              <a:defRPr sz="1600" b="0">
+                <a:solidFill>
+                  <a:srgbClr val="333333"/>
+                </a:solidFill>
+              </a:defRPr>
+            </a:pPr>
+            <a:r>
+              <a:t>• What's driving NJ IFR weakness (Flemington 76%, Lebanon 82%)?</a:t>
+            </a:r>
+          </a:p>
+        </p:txBody>
+      </p:sp>
+    </p:spTree>
+  </p:cSld>
+  <p:clrMapOvr>
+    <a:masterClrMapping/>
+  </p:clrMapOvr>
+</p:sld>
+</file>
+
+<file path=ppt/slides/slide15.xml><?xml version="1.0" encoding="utf-8"?>
+<p:sld xmlns:a="http://schemas.openxmlformats.org/drawingml/2006/main" xmlns:p="http://schemas.openxmlformats.org/presentationml/2006/main" xmlns:r="http://schemas.openxmlformats.org/officeDocument/2006/relationships">
+  <p:cSld>
+    <p:spTree>
+      <p:nvGrpSpPr>
+        <p:cNvPr id="1" name=""/>
+        <p:cNvGrpSpPr/>
+        <p:nvPr/>
+      </p:nvGrpSpPr>
+      <p:grpSpPr/>
+      <p:sp>
+        <p:nvSpPr>
+          <p:cNvPr id="2" name="TextBox 1"/>
+          <p:cNvSpPr txBox="1"/>
+          <p:nvPr/>
+        </p:nvSpPr>
+        <p:spPr>
+          <a:xfrm>
+            <a:off x="548640" y="365760"/>
+            <a:ext cx="10972800" cy="731520"/>
+          </a:xfrm>
+          <a:prstGeom prst="rect">
+            <a:avLst/>
+          </a:prstGeom>
+          <a:noFill/>
+        </p:spPr>
+        <p:txBody>
+          <a:bodyPr wrap="square">
+            <a:spAutoFit/>
+          </a:bodyPr>
+          <a:lstStyle/>
+          <a:p>
+            <a:pPr algn="l">
+              <a:defRPr sz="2800" b="1">
+                <a:solidFill>
+                  <a:srgbClr val="1A365D"/>
+                </a:solidFill>
+              </a:defRPr>
+            </a:pPr>
+            <a:r>
+              <a:t>Data &amp; resources</a:t>
+            </a:r>
+          </a:p>
+        </p:txBody>
+      </p:sp>
+      <p:sp>
+        <p:nvSpPr>
+          <p:cNvPr id="3" name="TextBox 2"/>
+          <p:cNvSpPr txBox="1"/>
+          <p:nvPr/>
+        </p:nvSpPr>
+        <p:spPr>
+          <a:xfrm>
+            <a:off x="731520" y="1188720"/>
+            <a:ext cx="10515600" cy="502920"/>
+          </a:xfrm>
+          <a:prstGeom prst="rect">
+            <a:avLst/>
+          </a:prstGeom>
+          <a:noFill/>
+        </p:spPr>
+        <p:txBody>
+          <a:bodyPr wrap="square">
+            <a:spAutoFit/>
+          </a:bodyPr>
+          <a:lstStyle/>
+          <a:p>
+            <a:pPr algn="l">
+              <a:defRPr sz="1600" b="0">
+                <a:solidFill>
+                  <a:srgbClr val="333333"/>
+                </a:solidFill>
+              </a:defRPr>
+            </a:pPr>
+            <a:r>
+              <a:t>• Pre-read: github.com/et844p/O2S/blob/cursor/safavieh-ceo-preread-b7d6/docs/small_parcel/safavieh_ceo_meeting_preread.md</a:t>
+            </a:r>
+          </a:p>
+        </p:txBody>
+      </p:sp>
+      <p:sp>
+        <p:nvSpPr>
+          <p:cNvPr id="4" name="TextBox 3"/>
+          <p:cNvSpPr txBox="1"/>
+          <p:nvPr/>
+        </p:nvSpPr>
+        <p:spPr>
+          <a:xfrm>
+            <a:off x="731520" y="1645920"/>
+            <a:ext cx="10515600" cy="502920"/>
+          </a:xfrm>
+          <a:prstGeom prst="rect">
+            <a:avLst/>
+          </a:prstGeom>
+          <a:noFill/>
+        </p:spPr>
+        <p:txBody>
+          <a:bodyPr wrap="square">
+            <a:spAutoFit/>
+          </a:bodyPr>
+          <a:lstStyle/>
+          <a:p>
+            <a:pPr algn="l">
+              <a:defRPr sz="1600" b="0">
+                <a:solidFill>
+                  <a:srgbClr val="333333"/>
+                </a:solidFill>
+              </a:defRPr>
+            </a:pPr>
+            <a:r>
+              <a:t>• Warehouse CSV: output/safavieh/safavieh_june_warehouse_analysis.csv</a:t>
+            </a:r>
+          </a:p>
+        </p:txBody>
+      </p:sp>
+      <p:sp>
+        <p:nvSpPr>
+          <p:cNvPr id="5" name="TextBox 4"/>
+          <p:cNvSpPr txBox="1"/>
+          <p:nvPr/>
+        </p:nvSpPr>
+        <p:spPr>
+          <a:xfrm>
+            <a:off x="731520" y="2103120"/>
+            <a:ext cx="10515600" cy="502920"/>
+          </a:xfrm>
+          <a:prstGeom prst="rect">
+            <a:avLst/>
+          </a:prstGeom>
+          <a:noFill/>
+        </p:spPr>
+        <p:txBody>
+          <a:bodyPr wrap="square">
+            <a:spAutoFit/>
+          </a:bodyPr>
+          <a:lstStyle/>
+          <a:p>
+            <a:pPr algn="l">
+              <a:defRPr sz="1600" b="0">
+                <a:solidFill>
+                  <a:srgbClr val="333333"/>
+                </a:solidFill>
+              </a:defRPr>
+            </a:pPr>
+            <a:r>
+              <a:t>• SQL: sql/safavieh_june_msbd_warehouse_analysis.sql</a:t>
+            </a:r>
+          </a:p>
+        </p:txBody>
+      </p:sp>
+      <p:sp>
+        <p:nvSpPr>
+          <p:cNvPr id="6" name="TextBox 5"/>
+          <p:cNvSpPr txBox="1"/>
+          <p:nvPr/>
+        </p:nvSpPr>
+        <p:spPr>
+          <a:xfrm>
+            <a:off x="731520" y="2560320"/>
+            <a:ext cx="10515600" cy="502920"/>
+          </a:xfrm>
+          <a:prstGeom prst="rect">
+            <a:avLst/>
+          </a:prstGeom>
+          <a:noFill/>
+        </p:spPr>
+        <p:txBody>
+          <a:bodyPr wrap="square">
+            <a:spAutoFit/>
+          </a:bodyPr>
+          <a:lstStyle/>
+          <a:p>
+            <a:pPr algn="l">
+              <a:defRPr sz="1600" b="0">
+                <a:solidFill>
+                  <a:srgbClr val="333333"/>
+                </a:solidFill>
+              </a:defRPr>
+            </a:pPr>
+            <a:r>
+              <a:t>• PR #16: github.com/et844p/O2S/pull/16</a:t>
+            </a:r>
+          </a:p>
+        </p:txBody>
+      </p:sp>
+    </p:spTree>
+  </p:cSld>
+  <p:clrMapOvr>
+    <a:masterClrMapping/>
+  </p:clrMapOvr>
+</p:sld>
+</file>
+
 <file path=ppt/slides/slide2.xml><?xml version="1.0" encoding="utf-8"?>
 <p:sld xmlns:a="http://schemas.openxmlformats.org/drawingml/2006/main" xmlns:p="http://schemas.openxmlformats.org/presentationml/2006/main" xmlns:r="http://schemas.openxmlformats.org/officeDocument/2006/relationships">
   <p:cSld>
@@ -5150,8 +6552,8 @@
         </p:nvSpPr>
         <p:spPr>
           <a:xfrm>
-            <a:off x="365760" y="228600"/>
-            <a:ext cx="10972800" cy="548640"/>
+            <a:off x="365760" y="182880"/>
+            <a:ext cx="10972800" cy="457200"/>
           </a:xfrm>
           <a:prstGeom prst="rect">
             <a:avLst/>
@@ -5165,558 +6567,42 @@
           <a:lstStyle/>
           <a:p>
             <a:pPr algn="l">
-              <a:defRPr sz="2400" b="1">
+              <a:defRPr sz="2000" b="1">
                 <a:solidFill>
                   <a:srgbClr val="1A365D"/>
                 </a:solidFill>
               </a:defRPr>
             </a:pPr>
             <a:r>
-              <a:t>Badging simulation — all speed tiers (June MSBD)</a:t>
-            </a:r>
-          </a:p>
-        </p:txBody>
-      </p:sp>
-      <p:graphicFrame>
-        <p:nvGraphicFramePr>
-          <p:cNvPr id="3" name="Table 2"/>
-          <p:cNvGraphicFramePr>
-            <a:graphicFrameLocks noGrp="1"/>
-          </p:cNvGraphicFramePr>
+              <a:t>IFR by warehouse (June MSBD)</a:t>
+            </a:r>
+          </a:p>
+        </p:txBody>
+      </p:sp>
+      <p:pic>
+        <p:nvPicPr>
+          <p:cNvPr id="3" name="Picture 2" descr="01_ifr_by_warehouse.png"/>
+          <p:cNvPicPr>
+            <a:picLocks noChangeAspect="1"/>
+          </p:cNvPicPr>
           <p:nvPr/>
-        </p:nvGraphicFramePr>
-        <p:xfrm>
-          <a:off x="457200" y="914400"/>
-          <a:ext cx="11247120" cy="1737360"/>
-        </p:xfrm>
-        <a:graphic>
-          <a:graphicData uri="http://schemas.openxmlformats.org/drawingml/2006/table">
-            <a:tbl>
-              <a:tblPr firstRow="1" bandRow="1">
-                <a:tableStyleId>{5C22544A-7EE6-4342-B048-85BDC9FD1C3A}</a:tableStyleId>
-              </a:tblPr>
-              <a:tblGrid>
-                <a:gridCol w="2249424"/>
-                <a:gridCol w="2249424"/>
-                <a:gridCol w="2249424"/>
-                <a:gridCol w="2249424"/>
-                <a:gridCol w="2249424"/>
-              </a:tblGrid>
-              <a:tr h="347472">
-                <a:tc>
-                  <a:txBody>
-                    <a:bodyPr/>
-                    <a:lstStyle/>
-                    <a:p>
-                      <a:pPr>
-                        <a:defRPr b="1" sz="1200">
-                          <a:solidFill>
-                            <a:srgbClr val="FFFFFF"/>
-                          </a:solidFill>
-                        </a:defRPr>
-                      </a:pPr>
-                      <a:r>
-                        <a:t>Scenario</a:t>
-                      </a:r>
-                    </a:p>
-                  </a:txBody>
-                  <a:tcPr>
-                    <a:solidFill>
-                      <a:srgbClr val="1A365D"/>
-                    </a:solidFill>
-                  </a:tcPr>
-                </a:tc>
-                <a:tc>
-                  <a:txBody>
-                    <a:bodyPr/>
-                    <a:lstStyle/>
-                    <a:p>
-                      <a:pPr>
-                        <a:defRPr b="1" sz="1200">
-                          <a:solidFill>
-                            <a:srgbClr val="FFFFFF"/>
-                          </a:solidFill>
-                        </a:defRPr>
-                      </a:pPr>
-                      <a:r>
-                        <a:t>1-day</a:t>
-                      </a:r>
-                    </a:p>
-                  </a:txBody>
-                  <a:tcPr>
-                    <a:solidFill>
-                      <a:srgbClr val="1A365D"/>
-                    </a:solidFill>
-                  </a:tcPr>
-                </a:tc>
-                <a:tc>
-                  <a:txBody>
-                    <a:bodyPr/>
-                    <a:lstStyle/>
-                    <a:p>
-                      <a:pPr>
-                        <a:defRPr b="1" sz="1200">
-                          <a:solidFill>
-                            <a:srgbClr val="FFFFFF"/>
-                          </a:solidFill>
-                        </a:defRPr>
-                      </a:pPr>
-                      <a:r>
-                        <a:t>2-day</a:t>
-                      </a:r>
-                    </a:p>
-                  </a:txBody>
-                  <a:tcPr>
-                    <a:solidFill>
-                      <a:srgbClr val="1A365D"/>
-                    </a:solidFill>
-                  </a:tcPr>
-                </a:tc>
-                <a:tc>
-                  <a:txBody>
-                    <a:bodyPr/>
-                    <a:lstStyle/>
-                    <a:p>
-                      <a:pPr>
-                        <a:defRPr b="1" sz="1200">
-                          <a:solidFill>
-                            <a:srgbClr val="FFFFFF"/>
-                          </a:solidFill>
-                        </a:defRPr>
-                      </a:pPr>
-                      <a:r>
-                        <a:t>3-day</a:t>
-                      </a:r>
-                    </a:p>
-                  </a:txBody>
-                  <a:tcPr>
-                    <a:solidFill>
-                      <a:srgbClr val="1A365D"/>
-                    </a:solidFill>
-                  </a:tcPr>
-                </a:tc>
-                <a:tc>
-                  <a:txBody>
-                    <a:bodyPr/>
-                    <a:lstStyle/>
-                    <a:p>
-                      <a:pPr>
-                        <a:defRPr b="1" sz="1200">
-                          <a:solidFill>
-                            <a:srgbClr val="FFFFFF"/>
-                          </a:solidFill>
-                        </a:defRPr>
-                      </a:pPr>
-                      <a:r>
-                        <a:t>Fast ≤5d</a:t>
-                      </a:r>
-                    </a:p>
-                  </a:txBody>
-                  <a:tcPr>
-                    <a:solidFill>
-                      <a:srgbClr val="1A365D"/>
-                    </a:solidFill>
-                  </a:tcPr>
-                </a:tc>
-              </a:tr>
-              <a:tr h="347472">
-                <a:tc>
-                  <a:txBody>
-                    <a:bodyPr/>
-                    <a:lstStyle/>
-                    <a:p>
-                      <a:pPr>
-                        <a:defRPr sz="1200"/>
-                      </a:pPr>
-                      <a:r>
-                        <a:t>June actual</a:t>
-                      </a:r>
-                    </a:p>
-                  </a:txBody>
-                  <a:tcPr/>
-                </a:tc>
-                <a:tc>
-                  <a:txBody>
-                    <a:bodyPr/>
-                    <a:lstStyle/>
-                    <a:p>
-                      <a:pPr>
-                        <a:defRPr sz="1200"/>
-                      </a:pPr>
-                      <a:r>
-                        <a:t>0.5%</a:t>
-                      </a:r>
-                    </a:p>
-                  </a:txBody>
-                  <a:tcPr/>
-                </a:tc>
-                <a:tc>
-                  <a:txBody>
-                    <a:bodyPr/>
-                    <a:lstStyle/>
-                    <a:p>
-                      <a:pPr>
-                        <a:defRPr sz="1200"/>
-                      </a:pPr>
-                      <a:r>
-                        <a:t>9.5%</a:t>
-                      </a:r>
-                    </a:p>
-                  </a:txBody>
-                  <a:tcPr/>
-                </a:tc>
-                <a:tc>
-                  <a:txBody>
-                    <a:bodyPr/>
-                    <a:lstStyle/>
-                    <a:p>
-                      <a:pPr>
-                        <a:defRPr sz="1200"/>
-                      </a:pPr>
-                      <a:r>
-                        <a:t>42.5%</a:t>
-                      </a:r>
-                    </a:p>
-                  </a:txBody>
-                  <a:tcPr/>
-                </a:tc>
-                <a:tc>
-                  <a:txBody>
-                    <a:bodyPr/>
-                    <a:lstStyle/>
-                    <a:p>
-                      <a:pPr>
-                        <a:defRPr sz="1200"/>
-                      </a:pPr>
-                      <a:r>
-                        <a:t>84.7%</a:t>
-                      </a:r>
-                    </a:p>
-                  </a:txBody>
-                  <a:tcPr/>
-                </a:tc>
-              </a:tr>
-              <a:tr h="347472">
-                <a:tc>
-                  <a:txBody>
-                    <a:bodyPr/>
-                    <a:lstStyle/>
-                    <a:p>
-                      <a:pPr>
-                        <a:defRPr sz="1200"/>
-                      </a:pPr>
-                      <a:r>
-                        <a:t>2pm + no cushion</a:t>
-                      </a:r>
-                    </a:p>
-                  </a:txBody>
-                  <a:tcPr/>
-                </a:tc>
-                <a:tc>
-                  <a:txBody>
-                    <a:bodyPr/>
-                    <a:lstStyle/>
-                    <a:p>
-                      <a:pPr>
-                        <a:defRPr sz="1200"/>
-                      </a:pPr>
-                      <a:r>
-                        <a:t>5.1%</a:t>
-                      </a:r>
-                    </a:p>
-                  </a:txBody>
-                  <a:tcPr/>
-                </a:tc>
-                <a:tc>
-                  <a:txBody>
-                    <a:bodyPr/>
-                    <a:lstStyle/>
-                    <a:p>
-                      <a:pPr>
-                        <a:defRPr sz="1200"/>
-                      </a:pPr>
-                      <a:r>
-                        <a:t>24.1%</a:t>
-                      </a:r>
-                    </a:p>
-                  </a:txBody>
-                  <a:tcPr/>
-                </a:tc>
-                <a:tc>
-                  <a:txBody>
-                    <a:bodyPr/>
-                    <a:lstStyle/>
-                    <a:p>
-                      <a:pPr>
-                        <a:defRPr sz="1200"/>
-                      </a:pPr>
-                      <a:r>
-                        <a:t>55.7%</a:t>
-                      </a:r>
-                    </a:p>
-                  </a:txBody>
-                  <a:tcPr/>
-                </a:tc>
-                <a:tc>
-                  <a:txBody>
-                    <a:bodyPr/>
-                    <a:lstStyle/>
-                    <a:p>
-                      <a:pPr>
-                        <a:defRPr sz="1200"/>
-                      </a:pPr>
-                      <a:r>
-                        <a:t>85.8%</a:t>
-                      </a:r>
-                    </a:p>
-                  </a:txBody>
-                  <a:tcPr/>
-                </a:tc>
-              </a:tr>
-              <a:tr h="347472">
-                <a:tc>
-                  <a:txBody>
-                    <a:bodyPr/>
-                    <a:lstStyle/>
-                    <a:p>
-                      <a:pPr>
-                        <a:defRPr sz="1200"/>
-                      </a:pPr>
-                      <a:r>
-                        <a:t>+ Weekend shipping</a:t>
-                      </a:r>
-                    </a:p>
-                  </a:txBody>
-                  <a:tcPr/>
-                </a:tc>
-                <a:tc>
-                  <a:txBody>
-                    <a:bodyPr/>
-                    <a:lstStyle/>
-                    <a:p>
-                      <a:pPr>
-                        <a:defRPr sz="1200"/>
-                      </a:pPr>
-                      <a:r>
-                        <a:t>6.3%</a:t>
-                      </a:r>
-                    </a:p>
-                  </a:txBody>
-                  <a:tcPr/>
-                </a:tc>
-                <a:tc>
-                  <a:txBody>
-                    <a:bodyPr/>
-                    <a:lstStyle/>
-                    <a:p>
-                      <a:pPr>
-                        <a:defRPr sz="1200"/>
-                      </a:pPr>
-                      <a:r>
-                        <a:t>26.4%</a:t>
-                      </a:r>
-                    </a:p>
-                  </a:txBody>
-                  <a:tcPr/>
-                </a:tc>
-                <a:tc>
-                  <a:txBody>
-                    <a:bodyPr/>
-                    <a:lstStyle/>
-                    <a:p>
-                      <a:pPr>
-                        <a:defRPr sz="1200"/>
-                      </a:pPr>
-                      <a:r>
-                        <a:t>59.5%</a:t>
-                      </a:r>
-                    </a:p>
-                  </a:txBody>
-                  <a:tcPr/>
-                </a:tc>
-                <a:tc>
-                  <a:txBody>
-                    <a:bodyPr/>
-                    <a:lstStyle/>
-                    <a:p>
-                      <a:pPr>
-                        <a:defRPr sz="1200"/>
-                      </a:pPr>
-                      <a:r>
-                        <a:t>86.9%</a:t>
-                      </a:r>
-                    </a:p>
-                  </a:txBody>
-                  <a:tcPr/>
-                </a:tc>
-              </a:tr>
-              <a:tr h="347472">
-                <a:tc>
-                  <a:txBody>
-                    <a:bodyPr/>
-                    <a:lstStyle/>
-                    <a:p>
-                      <a:pPr>
-                        <a:defRPr sz="1200"/>
-                      </a:pPr>
-                      <a:r>
-                        <a:t>Uplift (full vs June)</a:t>
-                      </a:r>
-                    </a:p>
-                  </a:txBody>
-                  <a:tcPr/>
-                </a:tc>
-                <a:tc>
-                  <a:txBody>
-                    <a:bodyPr/>
-                    <a:lstStyle/>
-                    <a:p>
-                      <a:pPr>
-                        <a:defRPr sz="1200">
-                          <a:solidFill>
-                            <a:srgbClr val="27AE60"/>
-                          </a:solidFill>
-                        </a:defRPr>
-                      </a:pPr>
-                      <a:r>
-                        <a:t>+5.8 pp</a:t>
-                      </a:r>
-                    </a:p>
-                  </a:txBody>
-                  <a:tcPr/>
-                </a:tc>
-                <a:tc>
-                  <a:txBody>
-                    <a:bodyPr/>
-                    <a:lstStyle/>
-                    <a:p>
-                      <a:pPr>
-                        <a:defRPr sz="1200">
-                          <a:solidFill>
-                            <a:srgbClr val="27AE60"/>
-                          </a:solidFill>
-                        </a:defRPr>
-                      </a:pPr>
-                      <a:r>
-                        <a:t>+17.1 pp</a:t>
-                      </a:r>
-                    </a:p>
-                  </a:txBody>
-                  <a:tcPr/>
-                </a:tc>
-                <a:tc>
-                  <a:txBody>
-                    <a:bodyPr/>
-                    <a:lstStyle/>
-                    <a:p>
-                      <a:pPr>
-                        <a:defRPr sz="1200">
-                          <a:solidFill>
-                            <a:srgbClr val="27AE60"/>
-                          </a:solidFill>
-                        </a:defRPr>
-                      </a:pPr>
-                      <a:r>
-                        <a:t>+17.0 pp</a:t>
-                      </a:r>
-                    </a:p>
-                  </a:txBody>
-                  <a:tcPr/>
-                </a:tc>
-                <a:tc>
-                  <a:txBody>
-                    <a:bodyPr/>
-                    <a:lstStyle/>
-                    <a:p>
-                      <a:pPr>
-                        <a:defRPr sz="1200">
-                          <a:solidFill>
-                            <a:srgbClr val="27AE60"/>
-                          </a:solidFill>
-                        </a:defRPr>
-                      </a:pPr>
-                      <a:r>
-                        <a:t>+2.2 pp</a:t>
-                      </a:r>
-                    </a:p>
-                  </a:txBody>
-                  <a:tcPr/>
-                </a:tc>
-              </a:tr>
-            </a:tbl>
-          </a:graphicData>
-        </a:graphic>
-      </p:graphicFrame>
-      <p:sp>
-        <p:nvSpPr>
-          <p:cNvPr id="4" name="TextBox 3"/>
-          <p:cNvSpPr txBox="1"/>
-          <p:nvPr/>
-        </p:nvSpPr>
-        <p:spPr>
-          <a:xfrm>
-            <a:off x="457200" y="3200400"/>
-            <a:ext cx="10972800" cy="1097280"/>
+        </p:nvPicPr>
+        <p:blipFill>
+          <a:blip r:embed="rId2"/>
+          <a:stretch>
+            <a:fillRect/>
+          </a:stretch>
+        </p:blipFill>
+        <p:spPr>
+          <a:xfrm>
+            <a:off x="320040" y="685800"/>
+            <a:ext cx="11521440" cy="6877078"/>
           </a:xfrm>
           <a:prstGeom prst="rect">
             <a:avLst/>
           </a:prstGeom>
-          <a:noFill/>
-        </p:spPr>
-        <p:txBody>
-          <a:bodyPr wrap="square">
-            <a:spAutoFit/>
-          </a:bodyPr>
-          <a:lstStyle/>
-          <a:p>
-            <a:pPr algn="l">
-              <a:defRPr sz="1300" b="0">
-                <a:solidFill>
-                  <a:srgbClr val="333333"/>
-                </a:solidFill>
-              </a:defRPr>
-            </a:pPr>
-            <a:r>
-              <a:t>Newly badged (full sim): 4,260 · 1-day | 12,406 · 2-day | 12,479 · 3-day | 1,644 · fast</a:t>
-            </a:r>
-          </a:p>
-        </p:txBody>
-      </p:sp>
-      <p:sp>
-        <p:nvSpPr>
-          <p:cNvPr id="5" name="TextBox 4"/>
-          <p:cNvSpPr txBox="1"/>
-          <p:nvPr/>
-        </p:nvSpPr>
-        <p:spPr>
-          <a:xfrm>
-            <a:off x="457200" y="4114800"/>
-            <a:ext cx="10972800" cy="1828800"/>
-          </a:xfrm>
-          <a:prstGeom prst="rect">
-            <a:avLst/>
-          </a:prstGeom>
-          <a:noFill/>
-        </p:spPr>
-        <p:txBody>
-          <a:bodyPr wrap="square">
-            <a:spAutoFit/>
-          </a:bodyPr>
-          <a:lstStyle/>
-          <a:p>
-            <a:pPr algn="l">
-              <a:defRPr sz="1200" b="0">
-                <a:solidFill>
-                  <a:srgbClr val="333333"/>
-                </a:solidFill>
-              </a:defRPr>
-            </a:pPr>
-            <a:r>
-              <a:t>Rules: remove cushion (−1d) · 2pm cutoff (−1d) · weekend ship (−1d). Badge tier = sim O2D ≤ N days.</a:t>
-            </a:r>
-          </a:p>
-        </p:txBody>
-      </p:sp>
+        </p:spPr>
+      </p:pic>
     </p:spTree>
   </p:cSld>
   <p:clrMapOvr>
@@ -5743,8 +6629,8 @@
         </p:nvSpPr>
         <p:spPr>
           <a:xfrm>
-            <a:off x="548640" y="365760"/>
-            <a:ext cx="10972800" cy="731520"/>
+            <a:off x="365760" y="182880"/>
+            <a:ext cx="10972800" cy="457200"/>
           </a:xfrm>
           <a:prstGeom prst="rect">
             <a:avLst/>
@@ -5758,193 +6644,42 @@
           <a:lstStyle/>
           <a:p>
             <a:pPr algn="l">
-              <a:defRPr sz="2800" b="1">
+              <a:defRPr sz="2000" b="1">
                 <a:solidFill>
                   <a:srgbClr val="1A365D"/>
                 </a:solidFill>
               </a:defRPr>
             </a:pPr>
             <a:r>
-              <a:t>Three policy levers</a:t>
-            </a:r>
-          </a:p>
-        </p:txBody>
-      </p:sp>
-      <p:sp>
-        <p:nvSpPr>
-          <p:cNvPr id="3" name="TextBox 2"/>
-          <p:cNvSpPr txBox="1"/>
+              <a:t>Same-day induction before 2pm — ops gap</a:t>
+            </a:r>
+          </a:p>
+        </p:txBody>
+      </p:sp>
+      <p:pic>
+        <p:nvPicPr>
+          <p:cNvPr id="3" name="Picture 2" descr="02_before_2pm_same_day_induction.png"/>
+          <p:cNvPicPr>
+            <a:picLocks noChangeAspect="1"/>
+          </p:cNvPicPr>
           <p:nvPr/>
-        </p:nvSpPr>
-        <p:spPr>
-          <a:xfrm>
-            <a:off x="731520" y="1188720"/>
-            <a:ext cx="10515600" cy="502920"/>
+        </p:nvPicPr>
+        <p:blipFill>
+          <a:blip r:embed="rId2"/>
+          <a:stretch>
+            <a:fillRect/>
+          </a:stretch>
+        </p:blipFill>
+        <p:spPr>
+          <a:xfrm>
+            <a:off x="320040" y="685800"/>
+            <a:ext cx="11521440" cy="6858554"/>
           </a:xfrm>
           <a:prstGeom prst="rect">
             <a:avLst/>
           </a:prstGeom>
-          <a:noFill/>
-        </p:spPr>
-        <p:txBody>
-          <a:bodyPr wrap="square">
-            <a:spAutoFit/>
-          </a:bodyPr>
-          <a:lstStyle/>
-          <a:p>
-            <a:pPr algn="l">
-              <a:defRPr sz="1600" b="0">
-                <a:solidFill>
-                  <a:srgbClr val="333333"/>
-                </a:solidFill>
-              </a:defRPr>
-            </a:pPr>
-            <a:r>
-              <a:t>• Zero cushion — lifts all tiers; largest at 2- and 3-day (+~14 pp)</a:t>
-            </a:r>
-          </a:p>
-        </p:txBody>
-      </p:sp>
-      <p:sp>
-        <p:nvSpPr>
-          <p:cNvPr id="4" name="TextBox 3"/>
-          <p:cNvSpPr txBox="1"/>
-          <p:nvPr/>
-        </p:nvSpPr>
-        <p:spPr>
-          <a:xfrm>
-            <a:off x="731520" y="1645920"/>
-            <a:ext cx="10515600" cy="502920"/>
-          </a:xfrm>
-          <a:prstGeom prst="rect">
-            <a:avLst/>
-          </a:prstGeom>
-          <a:noFill/>
-        </p:spPr>
-        <p:txBody>
-          <a:bodyPr wrap="square">
-            <a:spAutoFit/>
-          </a:bodyPr>
-          <a:lstStyle/>
-          <a:p>
-            <a:pPr algn="l">
-              <a:defRPr sz="1600" b="0">
-                <a:solidFill>
-                  <a:srgbClr val="333333"/>
-                </a:solidFill>
-              </a:defRPr>
-            </a:pPr>
-            <a:r>
-              <a:t>• 2:00 PM cutoff everywhere — Easton &amp; Port Wentworth biggest uplift</a:t>
-            </a:r>
-          </a:p>
-        </p:txBody>
-      </p:sp>
-      <p:sp>
-        <p:nvSpPr>
-          <p:cNvPr id="5" name="TextBox 4"/>
-          <p:cNvSpPr txBox="1"/>
-          <p:nvPr/>
-        </p:nvSpPr>
-        <p:spPr>
-          <a:xfrm>
-            <a:off x="731520" y="2103120"/>
-            <a:ext cx="10515600" cy="502920"/>
-          </a:xfrm>
-          <a:prstGeom prst="rect">
-            <a:avLst/>
-          </a:prstGeom>
-          <a:noFill/>
-        </p:spPr>
-        <p:txBody>
-          <a:bodyPr wrap="square">
-            <a:spAutoFit/>
-          </a:bodyPr>
-          <a:lstStyle/>
-          <a:p>
-            <a:pPr algn="l">
-              <a:defRPr sz="1600" b="0">
-                <a:solidFill>
-                  <a:srgbClr val="333333"/>
-                </a:solidFill>
-              </a:defRPr>
-            </a:pPr>
-            <a:r>
-              <a:t>• Weekend shipping — +4 pp at 3-day tier on top of policy</a:t>
-            </a:r>
-          </a:p>
-        </p:txBody>
-      </p:sp>
-      <p:sp>
-        <p:nvSpPr>
-          <p:cNvPr id="6" name="TextBox 5"/>
-          <p:cNvSpPr txBox="1"/>
-          <p:nvPr/>
-        </p:nvSpPr>
-        <p:spPr>
-          <a:xfrm>
-            <a:off x="731520" y="2560320"/>
-            <a:ext cx="10515600" cy="502920"/>
-          </a:xfrm>
-          <a:prstGeom prst="rect">
-            <a:avLst/>
-          </a:prstGeom>
-          <a:noFill/>
-        </p:spPr>
-        <p:txBody>
-          <a:bodyPr wrap="square">
-            <a:spAutoFit/>
-          </a:bodyPr>
-          <a:lstStyle/>
-          <a:p>
-            <a:pPr algn="l">
-              <a:defRPr sz="1600" b="0">
-                <a:solidFill>
-                  <a:srgbClr val="333333"/>
-                </a:solidFill>
-              </a:defRPr>
-            </a:pPr>
-            <a:r>
-              <a:t>• Combined: ~12.5k newly 2-day and 3-day badged orders in June</a:t>
-            </a:r>
-          </a:p>
-        </p:txBody>
-      </p:sp>
-      <p:sp>
-        <p:nvSpPr>
-          <p:cNvPr id="7" name="TextBox 6"/>
-          <p:cNvSpPr txBox="1"/>
-          <p:nvPr/>
-        </p:nvSpPr>
-        <p:spPr>
-          <a:xfrm>
-            <a:off x="731520" y="3017520"/>
-            <a:ext cx="10515600" cy="502920"/>
-          </a:xfrm>
-          <a:prstGeom prst="rect">
-            <a:avLst/>
-          </a:prstGeom>
-          <a:noFill/>
-        </p:spPr>
-        <p:txBody>
-          <a:bodyPr wrap="square">
-            <a:spAutoFit/>
-          </a:bodyPr>
-          <a:lstStyle/>
-          <a:p>
-            <a:pPr algn="l">
-              <a:defRPr sz="1600" b="0">
-                <a:solidFill>
-                  <a:srgbClr val="333333"/>
-                </a:solidFill>
-              </a:defRPr>
-            </a:pPr>
-            <a:r>
-              <a:t>• Fast badge (≤5d) only +2.2 pp — lead with 2/3-day story for CEO</a:t>
-            </a:r>
-          </a:p>
-        </p:txBody>
-      </p:sp>
+        </p:spPr>
+      </p:pic>
     </p:spTree>
   </p:cSld>
   <p:clrMapOvr>
@@ -5971,8 +6706,8 @@
         </p:nvSpPr>
         <p:spPr>
           <a:xfrm>
-            <a:off x="548640" y="365760"/>
-            <a:ext cx="10972800" cy="731520"/>
+            <a:off x="365760" y="182880"/>
+            <a:ext cx="10972800" cy="457200"/>
           </a:xfrm>
           <a:prstGeom prst="rect">
             <a:avLst/>
@@ -5986,193 +6721,42 @@
           <a:lstStyle/>
           <a:p>
             <a:pPr algn="l">
-              <a:defRPr sz="2800" b="1">
+              <a:defRPr sz="2000" b="1">
                 <a:solidFill>
                   <a:srgbClr val="1A365D"/>
                 </a:solidFill>
               </a:defRPr>
             </a:pPr>
             <a:r>
-              <a:t>Discussion questions for the CEO</a:t>
-            </a:r>
-          </a:p>
-        </p:txBody>
-      </p:sp>
-      <p:sp>
-        <p:nvSpPr>
-          <p:cNvPr id="3" name="TextBox 2"/>
-          <p:cNvSpPr txBox="1"/>
+              <a:t>IFR vs before-2pm induction opportunity</a:t>
+            </a:r>
+          </a:p>
+        </p:txBody>
+      </p:sp>
+      <p:pic>
+        <p:nvPicPr>
+          <p:cNvPr id="3" name="Picture 2" descr="03_ifr_vs_before_2pm_scatter.png"/>
+          <p:cNvPicPr>
+            <a:picLocks noChangeAspect="1"/>
+          </p:cNvPicPr>
           <p:nvPr/>
-        </p:nvSpPr>
-        <p:spPr>
-          <a:xfrm>
-            <a:off x="731520" y="1188720"/>
-            <a:ext cx="10515600" cy="502920"/>
+        </p:nvPicPr>
+        <p:blipFill>
+          <a:blip r:embed="rId2"/>
+          <a:stretch>
+            <a:fillRect/>
+          </a:stretch>
+        </p:blipFill>
+        <p:spPr>
+          <a:xfrm>
+            <a:off x="320040" y="685800"/>
+            <a:ext cx="11521440" cy="8930412"/>
           </a:xfrm>
           <a:prstGeom prst="rect">
             <a:avLst/>
           </a:prstGeom>
-          <a:noFill/>
-        </p:spPr>
-        <p:txBody>
-          <a:bodyPr wrap="square">
-            <a:spAutoFit/>
-          </a:bodyPr>
-          <a:lstStyle/>
-          <a:p>
-            <a:pPr algn="l">
-              <a:defRPr sz="1600" b="0">
-                <a:solidFill>
-                  <a:srgbClr val="333333"/>
-                </a:solidFill>
-              </a:defRPr>
-            </a:pPr>
-            <a:r>
-              <a:t>• Can every DC match Carlisle's 94% same-day induction before 2pm?</a:t>
-            </a:r>
-          </a:p>
-        </p:txBody>
-      </p:sp>
-      <p:sp>
-        <p:nvSpPr>
-          <p:cNvPr id="4" name="TextBox 3"/>
-          <p:cNvSpPr txBox="1"/>
-          <p:nvPr/>
-        </p:nvSpPr>
-        <p:spPr>
-          <a:xfrm>
-            <a:off x="731520" y="1645920"/>
-            <a:ext cx="10515600" cy="502920"/>
-          </a:xfrm>
-          <a:prstGeom prst="rect">
-            <a:avLst/>
-          </a:prstGeom>
-          <a:noFill/>
-        </p:spPr>
-        <p:txBody>
-          <a:bodyPr wrap="square">
-            <a:spAutoFit/>
-          </a:bodyPr>
-          <a:lstStyle/>
-          <a:p>
-            <a:pPr algn="l">
-              <a:defRPr sz="1600" b="0">
-                <a:solidFill>
-                  <a:srgbClr val="333333"/>
-                </a:solidFill>
-              </a:defRPr>
-            </a:pPr>
-            <a:r>
-              <a:t>• Will Safavieh standardize 2:00 PM cutoff and zero cushion network-wide?</a:t>
-            </a:r>
-          </a:p>
-        </p:txBody>
-      </p:sp>
-      <p:sp>
-        <p:nvSpPr>
-          <p:cNvPr id="5" name="TextBox 4"/>
-          <p:cNvSpPr txBox="1"/>
-          <p:nvPr/>
-        </p:nvSpPr>
-        <p:spPr>
-          <a:xfrm>
-            <a:off x="731520" y="2103120"/>
-            <a:ext cx="10515600" cy="502920"/>
-          </a:xfrm>
-          <a:prstGeom prst="rect">
-            <a:avLst/>
-          </a:prstGeom>
-          <a:noFill/>
-        </p:spPr>
-        <p:txBody>
-          <a:bodyPr wrap="square">
-            <a:spAutoFit/>
-          </a:bodyPr>
-          <a:lstStyle/>
-          <a:p>
-            <a:pPr algn="l">
-              <a:defRPr sz="1600" b="0">
-                <a:solidFill>
-                  <a:srgbClr val="333333"/>
-                </a:solidFill>
-              </a:defRPr>
-            </a:pPr>
-            <a:r>
-              <a:t>• Is weekend shipping feasible at NJ and PA nodes?</a:t>
-            </a:r>
-          </a:p>
-        </p:txBody>
-      </p:sp>
-      <p:sp>
-        <p:nvSpPr>
-          <p:cNvPr id="6" name="TextBox 5"/>
-          <p:cNvSpPr txBox="1"/>
-          <p:nvPr/>
-        </p:nvSpPr>
-        <p:spPr>
-          <a:xfrm>
-            <a:off x="731520" y="2560320"/>
-            <a:ext cx="10515600" cy="502920"/>
-          </a:xfrm>
-          <a:prstGeom prst="rect">
-            <a:avLst/>
-          </a:prstGeom>
-          <a:noFill/>
-        </p:spPr>
-        <p:txBody>
-          <a:bodyPr wrap="square">
-            <a:spAutoFit/>
-          </a:bodyPr>
-          <a:lstStyle/>
-          <a:p>
-            <a:pPr algn="l">
-              <a:defRPr sz="1600" b="0">
-                <a:solidFill>
-                  <a:srgbClr val="333333"/>
-                </a:solidFill>
-              </a:defRPr>
-            </a:pPr>
-            <a:r>
-              <a:t>• What FedEx pickup schedule runs at Easton, Lebanon, Port Wentworth today?</a:t>
-            </a:r>
-          </a:p>
-        </p:txBody>
-      </p:sp>
-      <p:sp>
-        <p:nvSpPr>
-          <p:cNvPr id="7" name="TextBox 6"/>
-          <p:cNvSpPr txBox="1"/>
-          <p:nvPr/>
-        </p:nvSpPr>
-        <p:spPr>
-          <a:xfrm>
-            <a:off x="731520" y="3017520"/>
-            <a:ext cx="10515600" cy="502920"/>
-          </a:xfrm>
-          <a:prstGeom prst="rect">
-            <a:avLst/>
-          </a:prstGeom>
-          <a:noFill/>
-        </p:spPr>
-        <p:txBody>
-          <a:bodyPr wrap="square">
-            <a:spAutoFit/>
-          </a:bodyPr>
-          <a:lstStyle/>
-          <a:p>
-            <a:pPr algn="l">
-              <a:defRPr sz="1600" b="0">
-                <a:solidFill>
-                  <a:srgbClr val="333333"/>
-                </a:solidFill>
-              </a:defRPr>
-            </a:pPr>
-            <a:r>
-              <a:t>• What's driving NJ IFR weakness (Flemington 76%, Lebanon 82%)?</a:t>
-            </a:r>
-          </a:p>
-        </p:txBody>
-      </p:sp>
+        </p:spPr>
+      </p:pic>
     </p:spTree>
   </p:cSld>
   <p:clrMapOvr>
@@ -6199,8 +6783,8 @@
         </p:nvSpPr>
         <p:spPr>
           <a:xfrm>
-            <a:off x="548640" y="365760"/>
-            <a:ext cx="10972800" cy="731520"/>
+            <a:off x="365760" y="182880"/>
+            <a:ext cx="10972800" cy="457200"/>
           </a:xfrm>
           <a:prstGeom prst="rect">
             <a:avLst/>
@@ -6214,158 +6798,42 @@
           <a:lstStyle/>
           <a:p>
             <a:pPr algn="l">
-              <a:defRPr sz="2800" b="1">
+              <a:defRPr sz="2000" b="1">
                 <a:solidFill>
                   <a:srgbClr val="1A365D"/>
                 </a:solidFill>
               </a:defRPr>
             </a:pPr>
             <a:r>
-              <a:t>Data &amp; resources</a:t>
-            </a:r>
-          </a:p>
-        </p:txBody>
-      </p:sp>
-      <p:sp>
-        <p:nvSpPr>
-          <p:cNvPr id="3" name="TextBox 2"/>
-          <p:cNvSpPr txBox="1"/>
+              <a:t>Badging coverage by speed tier</a:t>
+            </a:r>
+          </a:p>
+        </p:txBody>
+      </p:sp>
+      <p:pic>
+        <p:nvPicPr>
+          <p:cNvPr id="3" name="Picture 2" descr="04_badging_tiers_current_vs_sim.png"/>
+          <p:cNvPicPr>
+            <a:picLocks noChangeAspect="1"/>
+          </p:cNvPicPr>
           <p:nvPr/>
-        </p:nvSpPr>
-        <p:spPr>
-          <a:xfrm>
-            <a:off x="731520" y="1188720"/>
-            <a:ext cx="10515600" cy="502920"/>
+        </p:nvPicPr>
+        <p:blipFill>
+          <a:blip r:embed="rId2"/>
+          <a:stretch>
+            <a:fillRect/>
+          </a:stretch>
+        </p:blipFill>
+        <p:spPr>
+          <a:xfrm>
+            <a:off x="320040" y="685800"/>
+            <a:ext cx="11521440" cy="6987140"/>
           </a:xfrm>
           <a:prstGeom prst="rect">
             <a:avLst/>
           </a:prstGeom>
-          <a:noFill/>
-        </p:spPr>
-        <p:txBody>
-          <a:bodyPr wrap="square">
-            <a:spAutoFit/>
-          </a:bodyPr>
-          <a:lstStyle/>
-          <a:p>
-            <a:pPr algn="l">
-              <a:defRPr sz="1600" b="0">
-                <a:solidFill>
-                  <a:srgbClr val="333333"/>
-                </a:solidFill>
-              </a:defRPr>
-            </a:pPr>
-            <a:r>
-              <a:t>• Pre-read: github.com/et844p/O2S/blob/cursor/safavieh-ceo-preread-b7d6/docs/small_parcel/safavieh_ceo_meeting_preread.md</a:t>
-            </a:r>
-          </a:p>
-        </p:txBody>
-      </p:sp>
-      <p:sp>
-        <p:nvSpPr>
-          <p:cNvPr id="4" name="TextBox 3"/>
-          <p:cNvSpPr txBox="1"/>
-          <p:nvPr/>
-        </p:nvSpPr>
-        <p:spPr>
-          <a:xfrm>
-            <a:off x="731520" y="1645920"/>
-            <a:ext cx="10515600" cy="502920"/>
-          </a:xfrm>
-          <a:prstGeom prst="rect">
-            <a:avLst/>
-          </a:prstGeom>
-          <a:noFill/>
-        </p:spPr>
-        <p:txBody>
-          <a:bodyPr wrap="square">
-            <a:spAutoFit/>
-          </a:bodyPr>
-          <a:lstStyle/>
-          <a:p>
-            <a:pPr algn="l">
-              <a:defRPr sz="1600" b="0">
-                <a:solidFill>
-                  <a:srgbClr val="333333"/>
-                </a:solidFill>
-              </a:defRPr>
-            </a:pPr>
-            <a:r>
-              <a:t>• Warehouse CSV: output/safavieh/safavieh_june_warehouse_analysis.csv</a:t>
-            </a:r>
-          </a:p>
-        </p:txBody>
-      </p:sp>
-      <p:sp>
-        <p:nvSpPr>
-          <p:cNvPr id="5" name="TextBox 4"/>
-          <p:cNvSpPr txBox="1"/>
-          <p:nvPr/>
-        </p:nvSpPr>
-        <p:spPr>
-          <a:xfrm>
-            <a:off x="731520" y="2103120"/>
-            <a:ext cx="10515600" cy="502920"/>
-          </a:xfrm>
-          <a:prstGeom prst="rect">
-            <a:avLst/>
-          </a:prstGeom>
-          <a:noFill/>
-        </p:spPr>
-        <p:txBody>
-          <a:bodyPr wrap="square">
-            <a:spAutoFit/>
-          </a:bodyPr>
-          <a:lstStyle/>
-          <a:p>
-            <a:pPr algn="l">
-              <a:defRPr sz="1600" b="0">
-                <a:solidFill>
-                  <a:srgbClr val="333333"/>
-                </a:solidFill>
-              </a:defRPr>
-            </a:pPr>
-            <a:r>
-              <a:t>• SQL: sql/safavieh_june_msbd_warehouse_analysis.sql</a:t>
-            </a:r>
-          </a:p>
-        </p:txBody>
-      </p:sp>
-      <p:sp>
-        <p:nvSpPr>
-          <p:cNvPr id="6" name="TextBox 5"/>
-          <p:cNvSpPr txBox="1"/>
-          <p:nvPr/>
-        </p:nvSpPr>
-        <p:spPr>
-          <a:xfrm>
-            <a:off x="731520" y="2560320"/>
-            <a:ext cx="10515600" cy="502920"/>
-          </a:xfrm>
-          <a:prstGeom prst="rect">
-            <a:avLst/>
-          </a:prstGeom>
-          <a:noFill/>
-        </p:spPr>
-        <p:txBody>
-          <a:bodyPr wrap="square">
-            <a:spAutoFit/>
-          </a:bodyPr>
-          <a:lstStyle/>
-          <a:p>
-            <a:pPr algn="l">
-              <a:defRPr sz="1600" b="0">
-                <a:solidFill>
-                  <a:srgbClr val="333333"/>
-                </a:solidFill>
-              </a:defRPr>
-            </a:pPr>
-            <a:r>
-              <a:t>• PR #16: github.com/et844p/O2S/pull/16</a:t>
-            </a:r>
-          </a:p>
-        </p:txBody>
-      </p:sp>
+        </p:spPr>
+      </p:pic>
     </p:spTree>
   </p:cSld>
   <p:clrMapOvr>

</xml_diff>

<commit_message>
Fix badging sim: stated promise model with IsBeforeCutoff and Fri/Sat weekend
Reframe simulation on o2d_stated (not actual induction). Cutoff extension
uses toolkit IsBeforeCutoff=0 + hour<=14. Weekend shaves 1 day for all
Fri/Sat-placed orders. Re-run June MSBD analysis, charts, pre-read, and deck.

Co-authored-by: et844p <et844p@users.noreply.github.com>
</commit_message>
<xml_diff>
--- a/output/safavieh/Safavieh_CEO_June_MSBD.pptx
+++ b/output/safavieh/Safavieh_CEO_June_MSBD.pptx
@@ -27377,7 +27377,7 @@
               <a:defRPr sz="1400"/>
             </a:pPr>
             <a:r>
-              <a:t>• Is weekend shipping worth ops cost given modest fast-badge gain (+782 orders)?</a:t>
+              <a:t>• Weekend stated promise affects all Fri/Sat volume — +5,333 orders at 3-day tier</a:t>
             </a:r>
           </a:p>
           <a:p>
@@ -27512,7 +27512,15 @@
               <a:defRPr sz="1400"/>
             </a:pPr>
             <a:r>
-              <a:t>• 90.3% IFR in June — strong month; 68.3% same-day induction before 2pm (Mon–Fri)</a:t>
+              <a:t>• 90% IFR in June — strong month; 68.3% same-day induction before 2pm (Mon–Fri)</a:t>
+            </a:r>
+          </a:p>
+          <a:p>
+            <a:pPr>
+              <a:defRPr sz="1400"/>
+            </a:pPr>
+            <a:r>
+              <a:t>• Badging sim models STATED speed — not actual induction timing</a:t>
             </a:r>
           </a:p>
           <a:p>
@@ -27528,7 +27536,7 @@
               <a:defRPr sz="1400"/>
             </a:pPr>
             <a:r>
-              <a:t>• Policy (2pm + no cushion): +13 pp at 3-day badge — largest lever</a:t>
+              <a:t>• Full policy (2pm + no cushion + weekend promise): 7.1% 1-day · 27.5% 2-day · 60.6% 3-day</a:t>
             </a:r>
           </a:p>
           <a:p>
@@ -27536,7 +27544,7 @@
               <a:defRPr sz="1400"/>
             </a:pPr>
             <a:r>
-              <a:t>• Weekend shipping: +3.8 pp at 3-day after policy; only +1.1 pp at fast badge</a:t>
+              <a:t>• Weekend stated promise: all Fri/Sat placed (~17.9k) get −1 day — +7.3 pp at 3-day after policy</a:t>
             </a:r>
           </a:p>
           <a:p>
@@ -27544,7 +27552,7 @@
               <a:defRPr sz="1400"/>
             </a:pPr>
             <a:r>
-              <a:t>• Why weekend looks small on fast: 79% of Fri/Sat-not-weekend orders already ≤5d after policy</a:t>
+              <a:t>• 47% of Fri/Sat orders already ship Sat/Sun but are not promised that speed today</a:t>
             </a:r>
           </a:p>
           <a:p>
@@ -27552,7 +27560,7 @@
               <a:defRPr sz="1400"/>
             </a:pPr>
             <a:r>
-              <a:t>• Only 782 of 9,409 weekend-eligible orders flip fast with one more day shaved</a:t>
+              <a:t>• Cutoff extension: IsBeforeCutoff=0 + before 2pm (toolkit) — 6,671 orders</a:t>
             </a:r>
           </a:p>
         </p:txBody>
@@ -27740,7 +27748,7 @@
               <a:defRPr sz="1400"/>
             </a:pPr>
             <a:r>
-              <a:t>• 47% of Fri/Sat orders already inducted Sat/Sun — no sim adjustment</a:t>
+              <a:t>• Simulation shaves 1 day from stated O2S for ALL Fri/Sat-placed orders (HVE order_dow 5–6)</a:t>
             </a:r>
           </a:p>
           <a:p>
@@ -27748,7 +27756,7 @@
               <a:defRPr sz="1400"/>
             </a:pPr>
             <a:r>
-              <a:t>• 9,409 orders: Fri/Sat placed, NOT inducted Sat/Sun (weekend-eligible)</a:t>
+              <a:t>• Not conditioned on actual induction day — this is what we promise customers</a:t>
             </a:r>
           </a:p>
           <a:p>
@@ -27756,7 +27764,7 @@
               <a:defRPr sz="1400"/>
             </a:pPr>
             <a:r>
-              <a:t>• After policy: 7,487 already fast (≤5d) — shaving 1 day only flips 782 to fast</a:t>
+              <a:t>• 47% of Fri/Sat volume already ships Sat/Sun but is not promised that speed today</a:t>
             </a:r>
           </a:p>
           <a:p>
@@ -27764,7 +27772,7 @@
               <a:defRPr sz="1400"/>
             </a:pPr>
             <a:r>
-              <a:t>• 1,140 still &gt;5d after weekend shave — need &gt;1 day (avg o2d 4.77 after policy)</a:t>
+              <a:t>• ~17,881 Fri/Sat orders in June · incremental +5,333 at 3-day after cutoff/cushion policy</a:t>
             </a:r>
           </a:p>
           <a:p>
@@ -27772,7 +27780,7 @@
               <a:defRPr sz="1400"/>
             </a:pPr>
             <a:r>
-              <a:t>• Weekend matters more at 3-day: +2,762 orders (+3.8 pp) after policy</a:t>
+              <a:t>• Weekend incremental: +2.8 pp 1-day · +5.7 pp 2-day · +7.3 pp 3-day · +1.6 pp fast</a:t>
             </a:r>
           </a:p>
           <a:p>
@@ -27780,7 +27788,7 @@
               <a:defRPr sz="1400"/>
             </a:pPr>
             <a:r>
-              <a:t>• Conclusion: weekend is mid-tier badge lever, not primary fast-badge lever</a:t>
+              <a:t>• Ops must align: IFR + before-2pm induction prove delivery capability</a:t>
             </a:r>
           </a:p>
         </p:txBody>

</xml_diff>

<commit_message>
Weekday-only cutoff extension; clarify file paths and stated vs ops framing
Co-authored-by: et844p <et844p@users.noreply.github.com>
</commit_message>
<xml_diff>
--- a/output/safavieh/Safavieh_CEO_June_MSBD.pptx
+++ b/output/safavieh/Safavieh_CEO_June_MSBD.pptx
@@ -27377,7 +27377,7 @@
               <a:defRPr sz="1400"/>
             </a:pPr>
             <a:r>
-              <a:t>• Weekend stated promise affects all Fri/Sat volume — +5,333 orders at 3-day tier</a:t>
+              <a:t>• Weekend stated promise affects all Fri/Sat volume — +5,387 orders at 3-day tier</a:t>
             </a:r>
           </a:p>
           <a:p>
@@ -27520,7 +27520,7 @@
               <a:defRPr sz="1400"/>
             </a:pPr>
             <a:r>
-              <a:t>• Badging sim models STATED speed — not actual induction timing</a:t>
+              <a:t>• Full policy: 6.8% 1-day · 27.1% 2-day · 60.2% 3-day (badge simulation on o2d_stated)</a:t>
             </a:r>
           </a:p>
           <a:p>
@@ -27528,7 +27528,7 @@
               <a:defRPr sz="1400"/>
             </a:pPr>
             <a:r>
-              <a:t>• Badging today: 0.5% 1-day · 9.5% 2-day · 42.5% 3-day · 84.7% fast</a:t>
+              <a:t>• Weekend Sun MSBD: Fri/Sat placed (~17.9k) → o2d_stated −1 · +7.4 pp at 3-day after policy</a:t>
             </a:r>
           </a:p>
           <a:p>
@@ -27536,7 +27536,7 @@
               <a:defRPr sz="1400"/>
             </a:pPr>
             <a:r>
-              <a:t>• Full policy (2pm + no cushion + weekend promise): 7.1% 1-day · 27.5% 2-day · 60.6% 3-day</a:t>
+              <a:t>• Cutoff extension: weekdays only (Mon–Fri), after cutoff before 2pm — 5,557 orders</a:t>
             </a:r>
           </a:p>
           <a:p>
@@ -27544,23 +27544,7 @@
               <a:defRPr sz="1400"/>
             </a:pPr>
             <a:r>
-              <a:t>• Weekend stated promise: all Fri/Sat placed (~17.9k) get −1 day — +7.3 pp at 3-day after policy</a:t>
-            </a:r>
-          </a:p>
-          <a:p>
-            <a:pPr>
-              <a:defRPr sz="1400"/>
-            </a:pPr>
-            <a:r>
-              <a:t>• 47% of Fri/Sat orders already ship Sat/Sun but are not promised that speed today</a:t>
-            </a:r>
-          </a:p>
-          <a:p>
-            <a:pPr>
-              <a:defRPr sz="1400"/>
-            </a:pPr>
-            <a:r>
-              <a:t>• Cutoff extension: IsBeforeCutoff=0 + before 2pm (toolkit) — 6,671 orders</a:t>
+              <a:t>• Ops check: 68.3% same-day induct before 2pm · ~90% IFR — can they deliver faster badges?</a:t>
             </a:r>
           </a:p>
         </p:txBody>
@@ -27748,7 +27732,7 @@
               <a:defRPr sz="1400"/>
             </a:pPr>
             <a:r>
-              <a:t>• Simulation shaves 1 day from stated O2S for ALL Fri/Sat-placed orders (HVE order_dow 5–6)</a:t>
+              <a:t>• Fri/Sat placed eligible for Sunday MSBD → shave 1 day from o2d_stated (website badge)</a:t>
             </a:r>
           </a:p>
           <a:p>
@@ -27756,7 +27740,7 @@
               <a:defRPr sz="1400"/>
             </a:pPr>
             <a:r>
-              <a:t>• Not conditioned on actual induction day — this is what we promise customers</a:t>
+              <a:t>• Not based on whether they actually inducted Sat/Sun — this is the promise change</a:t>
             </a:r>
           </a:p>
           <a:p>
@@ -27764,7 +27748,7 @@
               <a:defRPr sz="1400"/>
             </a:pPr>
             <a:r>
-              <a:t>• 47% of Fri/Sat volume already ships Sat/Sun but is not promised that speed today</a:t>
+              <a:t>• ~17,881 Fri/Sat orders in June · incremental +5,387 at 3-day after cutoff/cushion</a:t>
             </a:r>
           </a:p>
           <a:p>
@@ -27772,7 +27756,7 @@
               <a:defRPr sz="1400"/>
             </a:pPr>
             <a:r>
-              <a:t>• ~17,881 Fri/Sat orders in June · incremental +5,333 at 3-day after cutoff/cushion policy</a:t>
+              <a:t>• 47% already ship Sat/Sun but are not promised that speed on the site today</a:t>
             </a:r>
           </a:p>
           <a:p>
@@ -27780,15 +27764,7 @@
               <a:defRPr sz="1400"/>
             </a:pPr>
             <a:r>
-              <a:t>• Weekend incremental: +2.8 pp 1-day · +5.7 pp 2-day · +7.3 pp 3-day · +1.6 pp fast</a:t>
-            </a:r>
-          </a:p>
-          <a:p>
-            <a:pPr>
-              <a:defRPr sz="1400"/>
-            </a:pPr>
-            <a:r>
-              <a:t>• Ops must align: IFR + before-2pm induction prove delivery capability</a:t>
+              <a:t>• Weekend incremental: +2.5 pp 1-day · +5.4 pp 2-day · +7.4 pp 3-day · +1.6 pp fast</a:t>
             </a:r>
           </a:p>
         </p:txBody>

</xml_diff>

<commit_message>
Add stacked cutoff + weekend opportunity charts (13/24/25) and slide
Co-authored-by: et844p <et844p@users.noreply.github.com>
</commit_message>
<xml_diff>
--- a/output/safavieh/Safavieh_CEO_June_MSBD.pptx
+++ b/output/safavieh/Safavieh_CEO_June_MSBD.pptx
@@ -21,6 +21,7 @@
     <p:sldId id="266" r:id="rId37"/>
     <p:sldId id="267" r:id="rId38"/>
     <p:sldId id="268" r:id="rId39"/>
+    <p:sldId id="269" r:id="rId40"/>
   </p:sldIdLst>
   <p:sldSz cy="5143500" cx="9144000"/>
   <p:notesSz cx="6858000" cy="9144000"/>
@@ -27153,6 +27154,79 @@
               <a:defRPr sz="2000" b="1"/>
             </a:pPr>
             <a:r>
+              <a:t>IFR vs before-2pm induction</a:t>
+            </a:r>
+          </a:p>
+        </p:txBody>
+      </p:sp>
+      <p:pic>
+        <p:nvPicPr>
+          <p:cNvPr id="3" name="Picture 2" descr="03_ifr_vs_before_2pm_scatter.png"/>
+          <p:cNvPicPr>
+            <a:picLocks noChangeAspect="1"/>
+          </p:cNvPicPr>
+          <p:nvPr/>
+        </p:nvPicPr>
+        <p:blipFill>
+          <a:blip r:embed="rId2"/>
+          <a:stretch>
+            <a:fillRect/>
+          </a:stretch>
+        </p:blipFill>
+        <p:spPr>
+          <a:xfrm>
+            <a:off x="320040" y="594360"/>
+            <a:ext cx="8503920" cy="6591494"/>
+          </a:xfrm>
+          <a:prstGeom prst="rect">
+            <a:avLst/>
+          </a:prstGeom>
+        </p:spPr>
+      </p:pic>
+    </p:spTree>
+  </p:cSld>
+  <p:clrMapOvr>
+    <a:masterClrMapping/>
+  </p:clrMapOvr>
+</p:sld>
+</file>
+
+<file path=ppt/slides/slide11.xml><?xml version="1.0" encoding="utf-8"?>
+<p:sld xmlns:a="http://schemas.openxmlformats.org/drawingml/2006/main" xmlns:p="http://schemas.openxmlformats.org/presentationml/2006/main" xmlns:r="http://schemas.openxmlformats.org/officeDocument/2006/relationships">
+  <p:cSld>
+    <p:spTree>
+      <p:nvGrpSpPr>
+        <p:cNvPr id="1" name=""/>
+        <p:cNvGrpSpPr/>
+        <p:nvPr/>
+      </p:nvGrpSpPr>
+      <p:grpSpPr/>
+      <p:sp>
+        <p:nvSpPr>
+          <p:cNvPr id="2" name="TextBox 1"/>
+          <p:cNvSpPr txBox="1"/>
+          <p:nvPr/>
+        </p:nvSpPr>
+        <p:spPr>
+          <a:xfrm>
+            <a:off x="365760" y="137160"/>
+            <a:ext cx="8229600" cy="457200"/>
+          </a:xfrm>
+          <a:prstGeom prst="rect">
+            <a:avLst/>
+          </a:prstGeom>
+          <a:noFill/>
+        </p:spPr>
+        <p:txBody>
+          <a:bodyPr wrap="none">
+            <a:spAutoFit/>
+          </a:bodyPr>
+          <a:lstStyle/>
+          <a:p>
+            <a:pPr>
+              <a:defRPr sz="2000" b="1"/>
+            </a:pPr>
+            <a:r>
               <a:t>Total badging opportunity by tier</a:t>
             </a:r>
           </a:p>
@@ -27190,7 +27264,7 @@
 </p:sld>
 </file>
 
-<file path=ppt/slides/slide11.xml><?xml version="1.0" encoding="utf-8"?>
+<file path=ppt/slides/slide12.xml><?xml version="1.0" encoding="utf-8"?>
 <p:sld xmlns:a="http://schemas.openxmlformats.org/drawingml/2006/main" xmlns:p="http://schemas.openxmlformats.org/presentationml/2006/main" xmlns:r="http://schemas.openxmlformats.org/officeDocument/2006/relationships">
   <p:cSld>
     <p:spTree>
@@ -27263,7 +27337,7 @@
 </p:sld>
 </file>
 
-<file path=ppt/slides/slide12.xml><?xml version="1.0" encoding="utf-8"?>
+<file path=ppt/slides/slide13.xml><?xml version="1.0" encoding="utf-8"?>
 <p:sld xmlns:a="http://schemas.openxmlformats.org/drawingml/2006/main" xmlns:p="http://schemas.openxmlformats.org/presentationml/2006/main" xmlns:r="http://schemas.openxmlformats.org/officeDocument/2006/relationships">
   <p:cSld>
     <p:spTree>
@@ -27340,7 +27414,7 @@
 </p:sld>
 </file>
 
-<file path=ppt/slides/slide13.xml><?xml version="1.0" encoding="utf-8"?>
+<file path=ppt/slides/slide14.xml><?xml version="1.0" encoding="utf-8"?>
 <p:sld xmlns:a="http://schemas.openxmlformats.org/drawingml/2006/main" xmlns:p="http://schemas.openxmlformats.org/presentationml/2006/main" xmlns:r="http://schemas.openxmlformats.org/officeDocument/2006/relationships">
   <p:cSld>
     <p:spTree>
@@ -27377,7 +27451,7 @@
               <a:defRPr sz="1400"/>
             </a:pPr>
             <a:r>
-              <a:t>• Weekend stated promise affects all Fri/Sat volume — +5,387 orders at 3-day tier</a:t>
+              <a:t>• Weekend stated promise: +9.0 pp at 3-day · 6,595 newly badged orders (Fri/Sat −1 vs current)</a:t>
             </a:r>
           </a:p>
           <a:p>
@@ -27520,7 +27594,7 @@
               <a:defRPr sz="1400"/>
             </a:pPr>
             <a:r>
-              <a:t>• Full policy: 6.8% 1-day · 27.1% 2-day · 60.2% 3-day (badge simulation on o2d_stated)</a:t>
+              <a:t>• Fri/Sat −1 o2d (Sun MSBD): +9.0 pp at 3-day · 6,595 newly badged orders vs current stated</a:t>
             </a:r>
           </a:p>
           <a:p>
@@ -27528,7 +27602,7 @@
               <a:defRPr sz="1400"/>
             </a:pPr>
             <a:r>
-              <a:t>• Weekend Sun MSBD: Fri/Sat placed (~17.9k) → o2d_stated −1 · +7.4 pp at 3-day after policy</a:t>
+              <a:t>• Full policy stack: 6.8% 1-day · 27.1% 2-day · 60.2% 3-day (includes cutoff + Fri/Sat −1)</a:t>
             </a:r>
           </a:p>
           <a:p>
@@ -27666,7 +27740,80 @@
               <a:defRPr sz="2000" b="1"/>
             </a:pPr>
             <a:r>
-              <a:t>Weekend shipping — incremental uplift by tier (after 2pm + no cushion)</a:t>
+              <a:t>Cutoff + weekend badge opportunity (stacked)</a:t>
+            </a:r>
+          </a:p>
+        </p:txBody>
+      </p:sp>
+      <p:pic>
+        <p:nvPicPr>
+          <p:cNvPr id="3" name="Picture 2" descr="24_cutoff_weekend_opportunity_stacked.png"/>
+          <p:cNvPicPr>
+            <a:picLocks noChangeAspect="1"/>
+          </p:cNvPicPr>
+          <p:nvPr/>
+        </p:nvPicPr>
+        <p:blipFill>
+          <a:blip r:embed="rId2"/>
+          <a:stretch>
+            <a:fillRect/>
+          </a:stretch>
+        </p:blipFill>
+        <p:spPr>
+          <a:xfrm>
+            <a:off x="320040" y="594360"/>
+            <a:ext cx="8503920" cy="5495458"/>
+          </a:xfrm>
+          <a:prstGeom prst="rect">
+            <a:avLst/>
+          </a:prstGeom>
+        </p:spPr>
+      </p:pic>
+    </p:spTree>
+  </p:cSld>
+  <p:clrMapOvr>
+    <a:masterClrMapping/>
+  </p:clrMapOvr>
+</p:sld>
+</file>
+
+<file path=ppt/slides/slide6.xml><?xml version="1.0" encoding="utf-8"?>
+<p:sld xmlns:a="http://schemas.openxmlformats.org/drawingml/2006/main" xmlns:p="http://schemas.openxmlformats.org/presentationml/2006/main" xmlns:r="http://schemas.openxmlformats.org/officeDocument/2006/relationships">
+  <p:cSld>
+    <p:spTree>
+      <p:nvGrpSpPr>
+        <p:cNvPr id="1" name=""/>
+        <p:cNvGrpSpPr/>
+        <p:nvPr/>
+      </p:nvGrpSpPr>
+      <p:grpSpPr/>
+      <p:sp>
+        <p:nvSpPr>
+          <p:cNvPr id="2" name="TextBox 1"/>
+          <p:cNvSpPr txBox="1"/>
+          <p:nvPr/>
+        </p:nvSpPr>
+        <p:spPr>
+          <a:xfrm>
+            <a:off x="365760" y="137160"/>
+            <a:ext cx="8229600" cy="457200"/>
+          </a:xfrm>
+          <a:prstGeom prst="rect">
+            <a:avLst/>
+          </a:prstGeom>
+          <a:noFill/>
+        </p:spPr>
+        <p:txBody>
+          <a:bodyPr wrap="none">
+            <a:spAutoFit/>
+          </a:bodyPr>
+          <a:lstStyle/>
+          <a:p>
+            <a:pPr>
+              <a:defRPr sz="2000" b="1"/>
+            </a:pPr>
+            <a:r>
+              <a:t>Sunday MSBD — Fri/Sat −1 o2d lift vs current stated</a:t>
             </a:r>
           </a:p>
         </p:txBody>
@@ -27703,7 +27850,7 @@
 </p:sld>
 </file>
 
-<file path=ppt/slides/slide6.xml><?xml version="1.0" encoding="utf-8"?>
+<file path=ppt/slides/slide7.xml><?xml version="1.0" encoding="utf-8"?>
 <p:sld xmlns:a="http://schemas.openxmlformats.org/drawingml/2006/main" xmlns:p="http://schemas.openxmlformats.org/presentationml/2006/main" xmlns:r="http://schemas.openxmlformats.org/officeDocument/2006/relationships">
   <p:cSld>
     <p:spTree>
@@ -27732,7 +27879,7 @@
               <a:defRPr sz="1400"/>
             </a:pPr>
             <a:r>
-              <a:t>• Fri/Sat placed eligible for Sunday MSBD → shave 1 day from o2d_stated (website badge)</a:t>
+              <a:t>• Fri/Sat placed → o2d_stated − 1 vs current stated (17,881 orders in June)</a:t>
             </a:r>
           </a:p>
           <a:p>
@@ -27740,7 +27887,7 @@
               <a:defRPr sz="1400"/>
             </a:pPr>
             <a:r>
-              <a:t>• Not based on whether they actually inducted Sat/Sun — this is the promise change</a:t>
+              <a:t>• Lift vs current: +1.8 pp 1-day · +3.7 pp 2-day · +9.0 pp 3-day · +1.9 pp fast</a:t>
             </a:r>
           </a:p>
           <a:p>
@@ -27748,7 +27895,7 @@
               <a:defRPr sz="1400"/>
             </a:pPr>
             <a:r>
-              <a:t>• ~17,881 Fri/Sat orders in June · incremental +5,387 at 3-day after cutoff/cushion</a:t>
+              <a:t>• 6,595 additional 3-day badges · 1,388 additional fast badges</a:t>
             </a:r>
           </a:p>
           <a:p>
@@ -27756,15 +27903,7 @@
               <a:defRPr sz="1400"/>
             </a:pPr>
             <a:r>
-              <a:t>• 47% already ship Sat/Sun but are not promised that speed on the site today</a:t>
-            </a:r>
-          </a:p>
-          <a:p>
-            <a:pPr>
-              <a:defRPr sz="1400"/>
-            </a:pPr>
-            <a:r>
-              <a:t>• Weekend incremental: +2.5 pp 1-day · +5.4 pp 2-day · +7.4 pp 3-day · +1.6 pp fast</a:t>
+              <a:t>• ~33% of Fri/Sat orders induct Sat/Sun in June (execution; separate from stated lift)</a:t>
             </a:r>
           </a:p>
         </p:txBody>
@@ -27777,7 +27916,7 @@
 </p:sld>
 </file>
 
-<file path=ppt/slides/slide7.xml><?xml version="1.0" encoding="utf-8"?>
+<file path=ppt/slides/slide8.xml><?xml version="1.0" encoding="utf-8"?>
 <p:sld xmlns:a="http://schemas.openxmlformats.org/drawingml/2006/main" xmlns:p="http://schemas.openxmlformats.org/presentationml/2006/main" xmlns:r="http://schemas.openxmlformats.org/officeDocument/2006/relationships">
   <p:cSld>
     <p:spTree>
@@ -27850,7 +27989,7 @@
 </p:sld>
 </file>
 
-<file path=ppt/slides/slide8.xml><?xml version="1.0" encoding="utf-8"?>
+<file path=ppt/slides/slide9.xml><?xml version="1.0" encoding="utf-8"?>
 <p:sld xmlns:a="http://schemas.openxmlformats.org/drawingml/2006/main" xmlns:p="http://schemas.openxmlformats.org/presentationml/2006/main" xmlns:r="http://schemas.openxmlformats.org/officeDocument/2006/relationships">
   <p:cSld>
     <p:spTree>
@@ -27909,79 +28048,6 @@
           <a:xfrm>
             <a:off x="320040" y="594360"/>
             <a:ext cx="8503920" cy="5062266"/>
-          </a:xfrm>
-          <a:prstGeom prst="rect">
-            <a:avLst/>
-          </a:prstGeom>
-        </p:spPr>
-      </p:pic>
-    </p:spTree>
-  </p:cSld>
-  <p:clrMapOvr>
-    <a:masterClrMapping/>
-  </p:clrMapOvr>
-</p:sld>
-</file>
-
-<file path=ppt/slides/slide9.xml><?xml version="1.0" encoding="utf-8"?>
-<p:sld xmlns:a="http://schemas.openxmlformats.org/drawingml/2006/main" xmlns:p="http://schemas.openxmlformats.org/presentationml/2006/main" xmlns:r="http://schemas.openxmlformats.org/officeDocument/2006/relationships">
-  <p:cSld>
-    <p:spTree>
-      <p:nvGrpSpPr>
-        <p:cNvPr id="1" name=""/>
-        <p:cNvGrpSpPr/>
-        <p:nvPr/>
-      </p:nvGrpSpPr>
-      <p:grpSpPr/>
-      <p:sp>
-        <p:nvSpPr>
-          <p:cNvPr id="2" name="TextBox 1"/>
-          <p:cNvSpPr txBox="1"/>
-          <p:nvPr/>
-        </p:nvSpPr>
-        <p:spPr>
-          <a:xfrm>
-            <a:off x="365760" y="137160"/>
-            <a:ext cx="8229600" cy="457200"/>
-          </a:xfrm>
-          <a:prstGeom prst="rect">
-            <a:avLst/>
-          </a:prstGeom>
-          <a:noFill/>
-        </p:spPr>
-        <p:txBody>
-          <a:bodyPr wrap="none">
-            <a:spAutoFit/>
-          </a:bodyPr>
-          <a:lstStyle/>
-          <a:p>
-            <a:pPr>
-              <a:defRPr sz="2000" b="1"/>
-            </a:pPr>
-            <a:r>
-              <a:t>IFR vs before-2pm induction</a:t>
-            </a:r>
-          </a:p>
-        </p:txBody>
-      </p:sp>
-      <p:pic>
-        <p:nvPicPr>
-          <p:cNvPr id="3" name="Picture 2" descr="03_ifr_vs_before_2pm_scatter.png"/>
-          <p:cNvPicPr>
-            <a:picLocks noChangeAspect="1"/>
-          </p:cNvPicPr>
-          <p:nvPr/>
-        </p:nvPicPr>
-        <p:blipFill>
-          <a:blip r:embed="rId2"/>
-          <a:stretch>
-            <a:fillRect/>
-          </a:stretch>
-        </p:blipFill>
-        <p:spPr>
-          <a:xfrm>
-            <a:off x="320040" y="594360"/>
-            <a:ext cx="8503920" cy="6591494"/>
           </a:xfrm>
           <a:prstGeom prst="rect">
             <a:avLst/>

</xml_diff>